<commit_message>
feat: Perfect Clone v3 - align coordinates, clarify filled vs hollow dots, precise labels
</commit_message>
<xml_diff>
--- a/output/4.pptx
+++ b/output/4.pptx
@@ -3104,8 +3104,8 @@
         </p:nvCxnSpPr>
         <p:spPr>
           <a:xfrm>
-            <a:off x="4114800.0" y="2571750.0"/>
-            <a:ext cx="3200400.0" cy="0.0"/>
+            <a:off x="4206240.0" y="2571750.0"/>
+            <a:ext cx="2880360.0" cy="0.0"/>
           </a:xfrm>
           <a:prstGeom prst="line">
             <a:avLst/>
@@ -3139,8 +3139,8 @@
         </p:nvCxnSpPr>
         <p:spPr>
           <a:xfrm flipV="1">
-            <a:off x="4572000.0" y="742950.0"/>
-            <a:ext cx="0.0" cy="2286000.0"/>
+            <a:off x="4572000.0" y="1428750.0"/>
+            <a:ext cx="0.0" cy="1371600.0"/>
           </a:xfrm>
           <a:prstGeom prst="line">
             <a:avLst/>
@@ -3174,8 +3174,8 @@
         </p:nvSpPr>
         <p:spPr>
           <a:xfrm>
-            <a:off x="4572000" y="1165083"/>
-            <a:ext cx="2743200" cy="1406667"/>
+            <a:off x="4572000" y="1752539"/>
+            <a:ext cx="2514600" cy="819211"/>
           </a:xfrm>
           <a:custGeom>
             <a:avLst/>
@@ -3184,2404 +3184,2404 @@
             <a:cxnLst/>
             <a:rect l="l" t="t" r="r" b="b"/>
             <a:pathLst>
-              <a:path w="2743200" h="1406667">
+              <a:path w="2514600" h="819211">
                 <a:moveTo>
-                  <a:pt x="0" y="1406667"/>
+                  <a:pt x="0" y="819211"/>
                 </a:moveTo>
                 <a:lnTo>
-                  <a:pt x="4580" y="1378932"/>
-                </a:lnTo>
-                <a:close/>
-                <a:lnTo>
-                  <a:pt x="9159" y="1353385"/>
-                </a:lnTo>
-                <a:close/>
-                <a:lnTo>
-                  <a:pt x="13739" y="1329911"/>
-                </a:lnTo>
-                <a:close/>
-                <a:lnTo>
-                  <a:pt x="18319" y="1308390"/>
-                </a:lnTo>
-                <a:close/>
-                <a:lnTo>
-                  <a:pt x="22898" y="1288706"/>
-                </a:lnTo>
-                <a:close/>
-                <a:lnTo>
-                  <a:pt x="27478" y="1270740"/>
-                </a:lnTo>
-                <a:close/>
-                <a:lnTo>
-                  <a:pt x="32057" y="1254376"/>
-                </a:lnTo>
-                <a:close/>
-                <a:lnTo>
-                  <a:pt x="36637" y="1239496"/>
-                </a:lnTo>
-                <a:close/>
-                <a:lnTo>
-                  <a:pt x="41217" y="1225982"/>
-                </a:lnTo>
-                <a:close/>
-                <a:lnTo>
-                  <a:pt x="45796" y="1213717"/>
-                </a:lnTo>
-                <a:close/>
-                <a:lnTo>
-                  <a:pt x="50376" y="1202582"/>
-                </a:lnTo>
-                <a:close/>
-                <a:lnTo>
-                  <a:pt x="54956" y="1192462"/>
-                </a:lnTo>
-                <a:close/>
-                <a:lnTo>
-                  <a:pt x="59535" y="1183237"/>
-                </a:lnTo>
-                <a:close/>
-                <a:lnTo>
-                  <a:pt x="64115" y="1174791"/>
-                </a:lnTo>
-                <a:close/>
-                <a:lnTo>
-                  <a:pt x="68694" y="1167005"/>
-                </a:lnTo>
-                <a:close/>
-                <a:lnTo>
-                  <a:pt x="73274" y="1159763"/>
-                </a:lnTo>
-                <a:close/>
-                <a:lnTo>
-                  <a:pt x="77854" y="1152947"/>
-                </a:lnTo>
-                <a:close/>
-                <a:lnTo>
-                  <a:pt x="82433" y="1146438"/>
-                </a:lnTo>
-                <a:close/>
-                <a:lnTo>
-                  <a:pt x="87013" y="1140121"/>
-                </a:lnTo>
-                <a:close/>
-                <a:lnTo>
-                  <a:pt x="91593" y="1133876"/>
-                </a:lnTo>
-                <a:close/>
-                <a:lnTo>
-                  <a:pt x="96172" y="1127612"/>
-                </a:lnTo>
-                <a:close/>
-                <a:lnTo>
-                  <a:pt x="100752" y="1121327"/>
-                </a:lnTo>
-                <a:close/>
-                <a:lnTo>
-                  <a:pt x="105332" y="1115038"/>
-                </a:lnTo>
-                <a:close/>
-                <a:lnTo>
-                  <a:pt x="109911" y="1108765"/>
-                </a:lnTo>
-                <a:close/>
-                <a:lnTo>
-                  <a:pt x="114491" y="1102526"/>
-                </a:lnTo>
-                <a:close/>
-                <a:lnTo>
-                  <a:pt x="119070" y="1096339"/>
-                </a:lnTo>
-                <a:close/>
-                <a:lnTo>
-                  <a:pt x="123650" y="1090224"/>
-                </a:lnTo>
-                <a:close/>
-                <a:lnTo>
-                  <a:pt x="128230" y="1084197"/>
-                </a:lnTo>
-                <a:close/>
-                <a:lnTo>
-                  <a:pt x="132809" y="1078279"/>
-                </a:lnTo>
-                <a:close/>
-                <a:lnTo>
-                  <a:pt x="137389" y="1072488"/>
-                </a:lnTo>
-                <a:close/>
-                <a:lnTo>
-                  <a:pt x="141969" y="1066835"/>
-                </a:lnTo>
-                <a:close/>
-                <a:lnTo>
-                  <a:pt x="146548" y="1061317"/>
-                </a:lnTo>
-                <a:close/>
-                <a:lnTo>
-                  <a:pt x="151128" y="1055922"/>
-                </a:lnTo>
-                <a:close/>
-                <a:lnTo>
-                  <a:pt x="155708" y="1050641"/>
-                </a:lnTo>
-                <a:close/>
-                <a:lnTo>
-                  <a:pt x="160287" y="1045463"/>
-                </a:lnTo>
-                <a:close/>
-                <a:lnTo>
-                  <a:pt x="164867" y="1040380"/>
-                </a:lnTo>
-                <a:close/>
-                <a:lnTo>
-                  <a:pt x="169446" y="1035382"/>
-                </a:lnTo>
-                <a:close/>
-                <a:lnTo>
-                  <a:pt x="174026" y="1030457"/>
-                </a:lnTo>
-                <a:close/>
-                <a:lnTo>
-                  <a:pt x="178606" y="1025597"/>
-                </a:lnTo>
-                <a:close/>
-                <a:lnTo>
-                  <a:pt x="183185" y="1020791"/>
-                </a:lnTo>
-                <a:close/>
-                <a:lnTo>
-                  <a:pt x="187765" y="1016032"/>
-                </a:lnTo>
-                <a:close/>
-                <a:lnTo>
-                  <a:pt x="192345" y="1011319"/>
-                </a:lnTo>
-                <a:close/>
-                <a:lnTo>
-                  <a:pt x="196924" y="1006651"/>
-                </a:lnTo>
-                <a:close/>
-                <a:lnTo>
-                  <a:pt x="201504" y="1002029"/>
-                </a:lnTo>
-                <a:close/>
-                <a:lnTo>
-                  <a:pt x="206083" y="997452"/>
-                </a:lnTo>
-                <a:close/>
-                <a:lnTo>
-                  <a:pt x="210663" y="992921"/>
-                </a:lnTo>
-                <a:close/>
-                <a:lnTo>
-                  <a:pt x="215243" y="988436"/>
-                </a:lnTo>
-                <a:close/>
-                <a:lnTo>
-                  <a:pt x="219822" y="983997"/>
-                </a:lnTo>
-                <a:close/>
-                <a:lnTo>
-                  <a:pt x="224402" y="979605"/>
-                </a:lnTo>
-                <a:close/>
-                <a:lnTo>
-                  <a:pt x="228982" y="975258"/>
-                </a:lnTo>
-                <a:close/>
-                <a:lnTo>
-                  <a:pt x="233561" y="970958"/>
-                </a:lnTo>
-                <a:close/>
-                <a:lnTo>
-                  <a:pt x="238141" y="966702"/>
-                </a:lnTo>
-                <a:close/>
-                <a:lnTo>
-                  <a:pt x="242721" y="962490"/>
-                </a:lnTo>
-                <a:close/>
-                <a:lnTo>
-                  <a:pt x="247300" y="958318"/>
-                </a:lnTo>
-                <a:close/>
-                <a:lnTo>
-                  <a:pt x="251880" y="954187"/>
-                </a:lnTo>
-                <a:close/>
-                <a:lnTo>
-                  <a:pt x="256459" y="950095"/>
-                </a:lnTo>
-                <a:close/>
-                <a:lnTo>
-                  <a:pt x="261039" y="946039"/>
-                </a:lnTo>
-                <a:close/>
-                <a:lnTo>
-                  <a:pt x="265619" y="942018"/>
-                </a:lnTo>
-                <a:close/>
-                <a:lnTo>
-                  <a:pt x="270198" y="938031"/>
-                </a:lnTo>
-                <a:close/>
-                <a:lnTo>
-                  <a:pt x="274778" y="934077"/>
-                </a:lnTo>
-                <a:close/>
-                <a:lnTo>
-                  <a:pt x="279358" y="930153"/>
-                </a:lnTo>
-                <a:close/>
-                <a:lnTo>
-                  <a:pt x="283937" y="926260"/>
-                </a:lnTo>
-                <a:close/>
-                <a:lnTo>
-                  <a:pt x="288517" y="922396"/>
-                </a:lnTo>
-                <a:close/>
-                <a:lnTo>
-                  <a:pt x="293096" y="918561"/>
-                </a:lnTo>
-                <a:close/>
-                <a:lnTo>
-                  <a:pt x="297676" y="914756"/>
-                </a:lnTo>
-                <a:close/>
-                <a:lnTo>
-                  <a:pt x="302256" y="910978"/>
-                </a:lnTo>
-                <a:close/>
-                <a:lnTo>
-                  <a:pt x="306835" y="907229"/>
-                </a:lnTo>
-                <a:close/>
-                <a:lnTo>
-                  <a:pt x="311415" y="903507"/>
-                </a:lnTo>
-                <a:close/>
-                <a:lnTo>
-                  <a:pt x="315995" y="899811"/>
-                </a:lnTo>
-                <a:close/>
-                <a:lnTo>
-                  <a:pt x="320574" y="896142"/>
-                </a:lnTo>
-                <a:close/>
-                <a:lnTo>
-                  <a:pt x="325154" y="892499"/>
-                </a:lnTo>
-                <a:close/>
-                <a:lnTo>
-                  <a:pt x="329734" y="888882"/>
-                </a:lnTo>
-                <a:close/>
-                <a:lnTo>
-                  <a:pt x="334313" y="885289"/>
-                </a:lnTo>
-                <a:close/>
-                <a:lnTo>
-                  <a:pt x="338893" y="881722"/>
-                </a:lnTo>
-                <a:close/>
-                <a:lnTo>
-                  <a:pt x="343472" y="878179"/>
-                </a:lnTo>
-                <a:close/>
-                <a:lnTo>
-                  <a:pt x="348052" y="874660"/>
-                </a:lnTo>
-                <a:close/>
-                <a:lnTo>
-                  <a:pt x="352632" y="871165"/>
-                </a:lnTo>
-                <a:close/>
-                <a:lnTo>
-                  <a:pt x="357211" y="867693"/>
-                </a:lnTo>
-                <a:close/>
-                <a:lnTo>
-                  <a:pt x="361791" y="864244"/>
-                </a:lnTo>
-                <a:close/>
-                <a:lnTo>
-                  <a:pt x="366371" y="860818"/>
-                </a:lnTo>
-                <a:close/>
-                <a:lnTo>
-                  <a:pt x="370950" y="857414"/>
-                </a:lnTo>
-                <a:close/>
-                <a:lnTo>
-                  <a:pt x="375530" y="854032"/>
-                </a:lnTo>
-                <a:close/>
-                <a:lnTo>
-                  <a:pt x="380110" y="850672"/>
-                </a:lnTo>
-                <a:close/>
-                <a:lnTo>
-                  <a:pt x="384689" y="847333"/>
-                </a:lnTo>
-                <a:close/>
-                <a:lnTo>
-                  <a:pt x="389269" y="844015"/>
-                </a:lnTo>
-                <a:close/>
-                <a:lnTo>
-                  <a:pt x="393848" y="840719"/>
-                </a:lnTo>
-                <a:close/>
-                <a:lnTo>
-                  <a:pt x="398428" y="837443"/>
-                </a:lnTo>
-                <a:close/>
-                <a:lnTo>
-                  <a:pt x="403008" y="834187"/>
-                </a:lnTo>
-                <a:close/>
-                <a:lnTo>
-                  <a:pt x="407587" y="830952"/>
-                </a:lnTo>
-                <a:close/>
-                <a:lnTo>
-                  <a:pt x="412167" y="827736"/>
-                </a:lnTo>
-                <a:close/>
-                <a:lnTo>
-                  <a:pt x="416747" y="824540"/>
-                </a:lnTo>
-                <a:close/>
-                <a:lnTo>
-                  <a:pt x="421326" y="821364"/>
-                </a:lnTo>
-                <a:close/>
-                <a:lnTo>
-                  <a:pt x="425906" y="818205"/>
-                </a:lnTo>
-                <a:close/>
-                <a:lnTo>
-                  <a:pt x="430485" y="815065"/>
-                </a:lnTo>
-                <a:close/>
-                <a:lnTo>
-                  <a:pt x="435065" y="811942"/>
-                </a:lnTo>
-                <a:close/>
-                <a:lnTo>
-                  <a:pt x="439645" y="808837"/>
-                </a:lnTo>
-                <a:close/>
-                <a:lnTo>
-                  <a:pt x="444224" y="805748"/>
-                </a:lnTo>
-                <a:close/>
-                <a:lnTo>
-                  <a:pt x="448804" y="802675"/>
-                </a:lnTo>
-                <a:close/>
-                <a:lnTo>
-                  <a:pt x="453384" y="799618"/>
-                </a:lnTo>
-                <a:close/>
-                <a:lnTo>
-                  <a:pt x="457963" y="796576"/>
-                </a:lnTo>
-                <a:close/>
-                <a:lnTo>
-                  <a:pt x="462543" y="793549"/>
-                </a:lnTo>
-                <a:close/>
-                <a:lnTo>
-                  <a:pt x="467123" y="790537"/>
-                </a:lnTo>
-                <a:close/>
-                <a:lnTo>
-                  <a:pt x="471702" y="787540"/>
-                </a:lnTo>
-                <a:close/>
-                <a:lnTo>
-                  <a:pt x="476282" y="784557"/>
-                </a:lnTo>
-                <a:close/>
-                <a:lnTo>
-                  <a:pt x="480861" y="781589"/>
-                </a:lnTo>
-                <a:close/>
-                <a:lnTo>
-                  <a:pt x="485441" y="778636"/>
-                </a:lnTo>
-                <a:close/>
-                <a:lnTo>
-                  <a:pt x="490021" y="775698"/>
-                </a:lnTo>
-                <a:close/>
-                <a:lnTo>
-                  <a:pt x="494600" y="772775"/>
-                </a:lnTo>
-                <a:close/>
-                <a:lnTo>
-                  <a:pt x="499180" y="769866"/>
-                </a:lnTo>
-                <a:close/>
-                <a:lnTo>
-                  <a:pt x="503760" y="766972"/>
-                </a:lnTo>
-                <a:close/>
-                <a:lnTo>
-                  <a:pt x="508339" y="764093"/>
-                </a:lnTo>
-                <a:close/>
-                <a:lnTo>
-                  <a:pt x="512919" y="761228"/>
-                </a:lnTo>
-                <a:close/>
-                <a:lnTo>
-                  <a:pt x="517498" y="758377"/>
-                </a:lnTo>
-                <a:close/>
-                <a:lnTo>
-                  <a:pt x="522078" y="755540"/>
-                </a:lnTo>
-                <a:close/>
-                <a:lnTo>
-                  <a:pt x="526658" y="752716"/>
-                </a:lnTo>
-                <a:close/>
-                <a:lnTo>
-                  <a:pt x="531237" y="749905"/>
-                </a:lnTo>
-                <a:close/>
-                <a:lnTo>
-                  <a:pt x="535817" y="747107"/>
-                </a:lnTo>
-                <a:close/>
-                <a:lnTo>
-                  <a:pt x="540397" y="744322"/>
-                </a:lnTo>
-                <a:close/>
-                <a:lnTo>
-                  <a:pt x="544976" y="741548"/>
-                </a:lnTo>
-                <a:close/>
-                <a:lnTo>
-                  <a:pt x="549556" y="738786"/>
-                </a:lnTo>
-                <a:close/>
-                <a:lnTo>
-                  <a:pt x="554136" y="736036"/>
-                </a:lnTo>
-                <a:close/>
-                <a:lnTo>
-                  <a:pt x="558715" y="733297"/>
-                </a:lnTo>
-                <a:close/>
-                <a:lnTo>
-                  <a:pt x="563295" y="730569"/>
-                </a:lnTo>
-                <a:close/>
-                <a:lnTo>
-                  <a:pt x="567874" y="727853"/>
-                </a:lnTo>
-                <a:close/>
-                <a:lnTo>
-                  <a:pt x="572454" y="725148"/>
-                </a:lnTo>
-                <a:close/>
-                <a:lnTo>
-                  <a:pt x="577034" y="722454"/>
-                </a:lnTo>
-                <a:close/>
-                <a:lnTo>
-                  <a:pt x="581613" y="719771"/>
-                </a:lnTo>
-                <a:close/>
-                <a:lnTo>
-                  <a:pt x="586193" y="717100"/>
-                </a:lnTo>
-                <a:close/>
-                <a:lnTo>
-                  <a:pt x="590773" y="714439"/>
-                </a:lnTo>
-                <a:close/>
-                <a:lnTo>
-                  <a:pt x="595352" y="711790"/>
-                </a:lnTo>
-                <a:close/>
-                <a:lnTo>
-                  <a:pt x="599932" y="709152"/>
-                </a:lnTo>
-                <a:close/>
-                <a:lnTo>
-                  <a:pt x="604512" y="706524"/>
-                </a:lnTo>
-                <a:close/>
-                <a:lnTo>
-                  <a:pt x="609091" y="703908"/>
-                </a:lnTo>
-                <a:close/>
-                <a:lnTo>
-                  <a:pt x="613671" y="701302"/>
-                </a:lnTo>
-                <a:close/>
-                <a:lnTo>
-                  <a:pt x="618250" y="698707"/>
-                </a:lnTo>
-                <a:close/>
-                <a:lnTo>
-                  <a:pt x="622830" y="696123"/>
-                </a:lnTo>
-                <a:close/>
-                <a:lnTo>
-                  <a:pt x="627410" y="693550"/>
-                </a:lnTo>
-                <a:close/>
-                <a:lnTo>
-                  <a:pt x="631989" y="690987"/>
-                </a:lnTo>
-                <a:close/>
-                <a:lnTo>
-                  <a:pt x="636569" y="688435"/>
-                </a:lnTo>
-                <a:close/>
-                <a:lnTo>
-                  <a:pt x="641149" y="685893"/>
-                </a:lnTo>
-                <a:close/>
-                <a:lnTo>
-                  <a:pt x="645728" y="683362"/>
-                </a:lnTo>
-                <a:close/>
-                <a:lnTo>
-                  <a:pt x="650308" y="680842"/>
-                </a:lnTo>
-                <a:close/>
-                <a:lnTo>
-                  <a:pt x="654887" y="678331"/>
-                </a:lnTo>
-                <a:close/>
-                <a:lnTo>
-                  <a:pt x="659467" y="675829"/>
-                </a:lnTo>
-                <a:close/>
-                <a:lnTo>
-                  <a:pt x="664047" y="673337"/>
-                </a:lnTo>
-                <a:close/>
-                <a:lnTo>
-                  <a:pt x="668626" y="670853"/>
-                </a:lnTo>
-                <a:close/>
-                <a:lnTo>
-                  <a:pt x="673206" y="668378"/>
-                </a:lnTo>
-                <a:close/>
-                <a:lnTo>
-                  <a:pt x="677786" y="665912"/>
-                </a:lnTo>
-                <a:close/>
-                <a:lnTo>
-                  <a:pt x="682365" y="663453"/>
-                </a:lnTo>
-                <a:close/>
-                <a:lnTo>
-                  <a:pt x="686945" y="661002"/>
-                </a:lnTo>
-                <a:close/>
-                <a:lnTo>
-                  <a:pt x="691525" y="658558"/>
-                </a:lnTo>
-                <a:close/>
-                <a:lnTo>
-                  <a:pt x="696104" y="656122"/>
-                </a:lnTo>
-                <a:close/>
-                <a:lnTo>
-                  <a:pt x="700684" y="653694"/>
-                </a:lnTo>
-                <a:close/>
-                <a:lnTo>
-                  <a:pt x="705263" y="651274"/>
-                </a:lnTo>
-                <a:close/>
-                <a:lnTo>
-                  <a:pt x="709843" y="648862"/>
-                </a:lnTo>
-                <a:close/>
-                <a:lnTo>
-                  <a:pt x="714423" y="646459"/>
-                </a:lnTo>
-                <a:close/>
-                <a:lnTo>
-                  <a:pt x="719002" y="644064"/>
-                </a:lnTo>
-                <a:close/>
-                <a:lnTo>
-                  <a:pt x="723582" y="641679"/>
-                </a:lnTo>
-                <a:close/>
-                <a:lnTo>
-                  <a:pt x="728162" y="639302"/>
-                </a:lnTo>
-                <a:close/>
-                <a:lnTo>
-                  <a:pt x="732741" y="636935"/>
-                </a:lnTo>
-                <a:close/>
-                <a:lnTo>
-                  <a:pt x="737321" y="634577"/>
-                </a:lnTo>
-                <a:close/>
-                <a:lnTo>
-                  <a:pt x="741901" y="632228"/>
-                </a:lnTo>
-                <a:close/>
-                <a:lnTo>
-                  <a:pt x="746480" y="629889"/>
-                </a:lnTo>
-                <a:close/>
-                <a:lnTo>
-                  <a:pt x="751060" y="627558"/>
-                </a:lnTo>
-                <a:close/>
-                <a:lnTo>
-                  <a:pt x="755639" y="625235"/>
-                </a:lnTo>
-                <a:close/>
-                <a:lnTo>
-                  <a:pt x="760219" y="622921"/>
-                </a:lnTo>
-                <a:close/>
-                <a:lnTo>
-                  <a:pt x="764799" y="620614"/>
-                </a:lnTo>
-                <a:close/>
-                <a:lnTo>
-                  <a:pt x="769378" y="618315"/>
-                </a:lnTo>
-                <a:close/>
-                <a:lnTo>
-                  <a:pt x="773958" y="616023"/>
-                </a:lnTo>
-                <a:close/>
-                <a:lnTo>
-                  <a:pt x="778538" y="613739"/>
-                </a:lnTo>
-                <a:close/>
-                <a:lnTo>
-                  <a:pt x="783117" y="611461"/>
-                </a:lnTo>
-                <a:close/>
-                <a:lnTo>
-                  <a:pt x="787697" y="609190"/>
-                </a:lnTo>
-                <a:close/>
-                <a:lnTo>
-                  <a:pt x="792276" y="606926"/>
-                </a:lnTo>
-                <a:close/>
-                <a:lnTo>
-                  <a:pt x="796856" y="604669"/>
-                </a:lnTo>
-                <a:close/>
-                <a:lnTo>
-                  <a:pt x="801436" y="602419"/>
-                </a:lnTo>
-                <a:close/>
-                <a:lnTo>
-                  <a:pt x="806015" y="600176"/>
-                </a:lnTo>
-                <a:close/>
-                <a:lnTo>
-                  <a:pt x="810595" y="597940"/>
-                </a:lnTo>
-                <a:close/>
-                <a:lnTo>
-                  <a:pt x="815175" y="595710"/>
-                </a:lnTo>
-                <a:close/>
-                <a:lnTo>
-                  <a:pt x="819754" y="593488"/>
-                </a:lnTo>
-                <a:close/>
-                <a:lnTo>
-                  <a:pt x="824334" y="591273"/>
-                </a:lnTo>
-                <a:close/>
-                <a:lnTo>
-                  <a:pt x="828914" y="589064"/>
-                </a:lnTo>
-                <a:close/>
-                <a:lnTo>
-                  <a:pt x="833493" y="586863"/>
-                </a:lnTo>
-                <a:close/>
-                <a:lnTo>
-                  <a:pt x="838073" y="584668"/>
-                </a:lnTo>
-                <a:close/>
-                <a:lnTo>
-                  <a:pt x="842652" y="582480"/>
-                </a:lnTo>
-                <a:close/>
-                <a:lnTo>
-                  <a:pt x="847232" y="580299"/>
-                </a:lnTo>
-                <a:close/>
-                <a:lnTo>
-                  <a:pt x="851812" y="578125"/>
-                </a:lnTo>
-                <a:close/>
-                <a:lnTo>
-                  <a:pt x="856391" y="575957"/>
-                </a:lnTo>
-                <a:close/>
-                <a:lnTo>
-                  <a:pt x="860971" y="573796"/>
-                </a:lnTo>
-                <a:close/>
-                <a:lnTo>
-                  <a:pt x="865551" y="571642"/>
-                </a:lnTo>
-                <a:close/>
-                <a:lnTo>
-                  <a:pt x="870130" y="569495"/>
-                </a:lnTo>
-                <a:close/>
-                <a:lnTo>
-                  <a:pt x="874710" y="567354"/>
-                </a:lnTo>
-                <a:close/>
-                <a:lnTo>
-                  <a:pt x="879289" y="565219"/>
-                </a:lnTo>
-                <a:close/>
-                <a:lnTo>
-                  <a:pt x="883869" y="563091"/>
-                </a:lnTo>
-                <a:close/>
-                <a:lnTo>
-                  <a:pt x="888449" y="560968"/>
-                </a:lnTo>
-                <a:close/>
-                <a:lnTo>
-                  <a:pt x="893028" y="558852"/>
-                </a:lnTo>
-                <a:close/>
-                <a:lnTo>
-                  <a:pt x="897608" y="556742"/>
-                </a:lnTo>
-                <a:close/>
-                <a:lnTo>
-                  <a:pt x="902188" y="554637"/>
-                </a:lnTo>
-                <a:close/>
-                <a:lnTo>
-                  <a:pt x="906767" y="552538"/>
-                </a:lnTo>
-                <a:close/>
-                <a:lnTo>
-                  <a:pt x="911347" y="550444"/>
-                </a:lnTo>
-                <a:close/>
-                <a:lnTo>
-                  <a:pt x="915927" y="548356"/>
-                </a:lnTo>
-                <a:close/>
-                <a:lnTo>
-                  <a:pt x="920506" y="546272"/>
-                </a:lnTo>
-                <a:close/>
-                <a:lnTo>
-                  <a:pt x="925086" y="544194"/>
-                </a:lnTo>
-                <a:close/>
-                <a:lnTo>
-                  <a:pt x="929665" y="542121"/>
-                </a:lnTo>
-                <a:close/>
-                <a:lnTo>
-                  <a:pt x="934245" y="540054"/>
-                </a:lnTo>
-                <a:close/>
-                <a:lnTo>
-                  <a:pt x="938825" y="537992"/>
-                </a:lnTo>
-                <a:close/>
-                <a:lnTo>
-                  <a:pt x="943404" y="535936"/>
-                </a:lnTo>
-                <a:close/>
-                <a:lnTo>
-                  <a:pt x="947984" y="533885"/>
-                </a:lnTo>
-                <a:close/>
-                <a:lnTo>
-                  <a:pt x="952564" y="531839"/>
-                </a:lnTo>
-                <a:close/>
-                <a:lnTo>
-                  <a:pt x="957143" y="529800"/>
-                </a:lnTo>
-                <a:close/>
-                <a:lnTo>
-                  <a:pt x="961723" y="527766"/>
-                </a:lnTo>
-                <a:close/>
-                <a:lnTo>
-                  <a:pt x="966303" y="525738"/>
-                </a:lnTo>
-                <a:close/>
-                <a:lnTo>
-                  <a:pt x="970882" y="523716"/>
-                </a:lnTo>
-                <a:close/>
-                <a:lnTo>
-                  <a:pt x="975462" y="521699"/>
-                </a:lnTo>
-                <a:close/>
-                <a:lnTo>
-                  <a:pt x="980041" y="519688"/>
-                </a:lnTo>
-                <a:close/>
-                <a:lnTo>
-                  <a:pt x="984621" y="517681"/>
-                </a:lnTo>
-                <a:close/>
-                <a:lnTo>
-                  <a:pt x="989201" y="515680"/>
-                </a:lnTo>
-                <a:close/>
-                <a:lnTo>
-                  <a:pt x="993780" y="513685"/>
-                </a:lnTo>
-                <a:close/>
-                <a:lnTo>
-                  <a:pt x="998360" y="511694"/>
-                </a:lnTo>
-                <a:close/>
-                <a:lnTo>
-                  <a:pt x="1002940" y="509707"/>
-                </a:lnTo>
-                <a:close/>
-                <a:lnTo>
-                  <a:pt x="1007519" y="507726"/>
-                </a:lnTo>
-                <a:close/>
-                <a:lnTo>
-                  <a:pt x="1012099" y="505749"/>
-                </a:lnTo>
-                <a:close/>
-                <a:lnTo>
-                  <a:pt x="1016678" y="503777"/>
-                </a:lnTo>
-                <a:close/>
-                <a:lnTo>
-                  <a:pt x="1021258" y="501810"/>
-                </a:lnTo>
-                <a:close/>
-                <a:lnTo>
-                  <a:pt x="1025838" y="499848"/>
-                </a:lnTo>
-                <a:close/>
-                <a:lnTo>
-                  <a:pt x="1030417" y="497891"/>
-                </a:lnTo>
-                <a:close/>
-                <a:lnTo>
-                  <a:pt x="1034997" y="495940"/>
-                </a:lnTo>
-                <a:close/>
-                <a:lnTo>
-                  <a:pt x="1039577" y="493994"/>
-                </a:lnTo>
-                <a:close/>
-                <a:lnTo>
-                  <a:pt x="1044156" y="492054"/>
-                </a:lnTo>
-                <a:close/>
-                <a:lnTo>
-                  <a:pt x="1048736" y="490119"/>
-                </a:lnTo>
-                <a:close/>
-                <a:lnTo>
-                  <a:pt x="1053316" y="488191"/>
-                </a:lnTo>
-                <a:close/>
-                <a:lnTo>
-                  <a:pt x="1057895" y="486269"/>
-                </a:lnTo>
-                <a:close/>
-                <a:lnTo>
-                  <a:pt x="1062475" y="484352"/>
-                </a:lnTo>
-                <a:close/>
-                <a:lnTo>
-                  <a:pt x="1067054" y="482441"/>
-                </a:lnTo>
-                <a:close/>
-                <a:lnTo>
-                  <a:pt x="1071634" y="480536"/>
-                </a:lnTo>
-                <a:close/>
-                <a:lnTo>
-                  <a:pt x="1076214" y="478636"/>
-                </a:lnTo>
-                <a:close/>
-                <a:lnTo>
-                  <a:pt x="1080793" y="476740"/>
-                </a:lnTo>
-                <a:close/>
-                <a:lnTo>
-                  <a:pt x="1085373" y="474850"/>
-                </a:lnTo>
-                <a:close/>
-                <a:lnTo>
-                  <a:pt x="1089953" y="472964"/>
-                </a:lnTo>
-                <a:close/>
-                <a:lnTo>
-                  <a:pt x="1094532" y="471083"/>
-                </a:lnTo>
-                <a:close/>
-                <a:lnTo>
-                  <a:pt x="1099112" y="469205"/>
-                </a:lnTo>
-                <a:close/>
-                <a:lnTo>
-                  <a:pt x="1103691" y="467332"/>
-                </a:lnTo>
-                <a:close/>
-                <a:lnTo>
-                  <a:pt x="1108271" y="465463"/>
-                </a:lnTo>
-                <a:close/>
-                <a:lnTo>
-                  <a:pt x="1112851" y="463598"/>
-                </a:lnTo>
-                <a:close/>
-                <a:lnTo>
-                  <a:pt x="1117430" y="461738"/>
-                </a:lnTo>
-                <a:close/>
-                <a:lnTo>
-                  <a:pt x="1122010" y="459883"/>
-                </a:lnTo>
-                <a:close/>
-                <a:lnTo>
-                  <a:pt x="1126590" y="458032"/>
-                </a:lnTo>
-                <a:close/>
-                <a:lnTo>
-                  <a:pt x="1131169" y="456185"/>
-                </a:lnTo>
-                <a:close/>
-                <a:lnTo>
-                  <a:pt x="1135749" y="454344"/>
-                </a:lnTo>
-                <a:close/>
-                <a:lnTo>
-                  <a:pt x="1140329" y="452508"/>
-                </a:lnTo>
-                <a:close/>
-                <a:lnTo>
-                  <a:pt x="1144908" y="450677"/>
-                </a:lnTo>
-                <a:close/>
-                <a:lnTo>
-                  <a:pt x="1149488" y="448851"/>
-                </a:lnTo>
-                <a:close/>
-                <a:lnTo>
-                  <a:pt x="1154067" y="447029"/>
-                </a:lnTo>
-                <a:close/>
-                <a:lnTo>
-                  <a:pt x="1158647" y="445212"/>
-                </a:lnTo>
-                <a:close/>
-                <a:lnTo>
-                  <a:pt x="1163227" y="443400"/>
-                </a:lnTo>
-                <a:close/>
-                <a:lnTo>
-                  <a:pt x="1167806" y="441592"/>
-                </a:lnTo>
-                <a:close/>
-                <a:lnTo>
-                  <a:pt x="1172386" y="439787"/>
-                </a:lnTo>
-                <a:close/>
-                <a:lnTo>
-                  <a:pt x="1176966" y="437987"/>
-                </a:lnTo>
-                <a:close/>
-                <a:lnTo>
-                  <a:pt x="1181545" y="436189"/>
-                </a:lnTo>
-                <a:close/>
-                <a:lnTo>
-                  <a:pt x="1186125" y="434395"/>
-                </a:lnTo>
-                <a:close/>
-                <a:lnTo>
-                  <a:pt x="1190705" y="432604"/>
-                </a:lnTo>
-                <a:close/>
-                <a:lnTo>
-                  <a:pt x="1195284" y="430815"/>
-                </a:lnTo>
-                <a:close/>
-                <a:lnTo>
-                  <a:pt x="1199864" y="429030"/>
-                </a:lnTo>
-                <a:close/>
-                <a:lnTo>
-                  <a:pt x="1204443" y="427248"/>
-                </a:lnTo>
-                <a:close/>
-                <a:lnTo>
-                  <a:pt x="1209023" y="425471"/>
-                </a:lnTo>
-                <a:close/>
-                <a:lnTo>
-                  <a:pt x="1213603" y="423697"/>
-                </a:lnTo>
-                <a:close/>
-                <a:lnTo>
-                  <a:pt x="1218182" y="421927"/>
-                </a:lnTo>
-                <a:close/>
-                <a:lnTo>
-                  <a:pt x="1222762" y="420163"/>
-                </a:lnTo>
-                <a:close/>
-                <a:lnTo>
-                  <a:pt x="1227342" y="418403"/>
-                </a:lnTo>
-                <a:close/>
-                <a:lnTo>
-                  <a:pt x="1231921" y="416649"/>
-                </a:lnTo>
-                <a:close/>
-                <a:lnTo>
-                  <a:pt x="1236501" y="414900"/>
-                </a:lnTo>
-                <a:close/>
-                <a:lnTo>
-                  <a:pt x="1241080" y="413156"/>
-                </a:lnTo>
-                <a:close/>
-                <a:lnTo>
-                  <a:pt x="1245660" y="411418"/>
-                </a:lnTo>
-                <a:close/>
-                <a:lnTo>
-                  <a:pt x="1250240" y="409685"/>
-                </a:lnTo>
-                <a:close/>
-                <a:lnTo>
-                  <a:pt x="1254819" y="407956"/>
-                </a:lnTo>
-                <a:close/>
-                <a:lnTo>
-                  <a:pt x="1259399" y="406231"/>
-                </a:lnTo>
-                <a:close/>
-                <a:lnTo>
-                  <a:pt x="1263979" y="404509"/>
-                </a:lnTo>
-                <a:close/>
-                <a:lnTo>
-                  <a:pt x="1268558" y="402791"/>
-                </a:lnTo>
-                <a:close/>
-                <a:lnTo>
-                  <a:pt x="1273138" y="401076"/>
-                </a:lnTo>
-                <a:close/>
-                <a:lnTo>
-                  <a:pt x="1277718" y="399362"/>
-                </a:lnTo>
-                <a:close/>
-                <a:lnTo>
-                  <a:pt x="1282297" y="397651"/>
-                </a:lnTo>
-                <a:close/>
-                <a:lnTo>
-                  <a:pt x="1286877" y="395942"/>
-                </a:lnTo>
-                <a:close/>
-                <a:lnTo>
-                  <a:pt x="1291456" y="394235"/>
-                </a:lnTo>
-                <a:close/>
-                <a:lnTo>
-                  <a:pt x="1296036" y="392531"/>
-                </a:lnTo>
-                <a:close/>
-                <a:lnTo>
-                  <a:pt x="1300616" y="390831"/>
-                </a:lnTo>
-                <a:close/>
-                <a:lnTo>
-                  <a:pt x="1305195" y="389134"/>
-                </a:lnTo>
-                <a:close/>
-                <a:lnTo>
-                  <a:pt x="1309775" y="387442"/>
-                </a:lnTo>
-                <a:close/>
-                <a:lnTo>
-                  <a:pt x="1314355" y="385755"/>
-                </a:lnTo>
-                <a:close/>
-                <a:lnTo>
-                  <a:pt x="1318934" y="384073"/>
-                </a:lnTo>
-                <a:close/>
-                <a:lnTo>
-                  <a:pt x="1323514" y="382397"/>
-                </a:lnTo>
-                <a:close/>
-                <a:lnTo>
-                  <a:pt x="1328093" y="380727"/>
-                </a:lnTo>
-                <a:close/>
-                <a:lnTo>
-                  <a:pt x="1332673" y="379063"/>
-                </a:lnTo>
-                <a:close/>
-                <a:lnTo>
-                  <a:pt x="1337253" y="377405"/>
-                </a:lnTo>
-                <a:close/>
-                <a:lnTo>
-                  <a:pt x="1341832" y="375752"/>
-                </a:lnTo>
-                <a:close/>
-                <a:lnTo>
-                  <a:pt x="1346412" y="374102"/>
-                </a:lnTo>
-                <a:close/>
-                <a:lnTo>
-                  <a:pt x="1350992" y="372457"/>
-                </a:lnTo>
-                <a:close/>
-                <a:lnTo>
-                  <a:pt x="1355571" y="370813"/>
-                </a:lnTo>
-                <a:close/>
-                <a:lnTo>
-                  <a:pt x="1360151" y="369172"/>
-                </a:lnTo>
-                <a:close/>
-                <a:lnTo>
-                  <a:pt x="1364731" y="367533"/>
-                </a:lnTo>
-                <a:close/>
-                <a:lnTo>
-                  <a:pt x="1369310" y="365893"/>
-                </a:lnTo>
-                <a:close/>
-                <a:lnTo>
-                  <a:pt x="1373890" y="364254"/>
-                </a:lnTo>
-                <a:close/>
-                <a:lnTo>
-                  <a:pt x="1378469" y="362616"/>
-                </a:lnTo>
-                <a:close/>
-                <a:lnTo>
-                  <a:pt x="1383049" y="360979"/>
-                </a:lnTo>
-                <a:close/>
-                <a:lnTo>
-                  <a:pt x="1387629" y="359345"/>
-                </a:lnTo>
-                <a:close/>
-                <a:lnTo>
-                  <a:pt x="1392208" y="357716"/>
-                </a:lnTo>
-                <a:close/>
-                <a:lnTo>
-                  <a:pt x="1396788" y="356093"/>
-                </a:lnTo>
-                <a:close/>
-                <a:lnTo>
-                  <a:pt x="1401368" y="354479"/>
-                </a:lnTo>
-                <a:close/>
-                <a:lnTo>
-                  <a:pt x="1405947" y="352873"/>
-                </a:lnTo>
-                <a:close/>
-                <a:lnTo>
-                  <a:pt x="1410527" y="351278"/>
-                </a:lnTo>
-                <a:close/>
-                <a:lnTo>
-                  <a:pt x="1415107" y="349695"/>
-                </a:lnTo>
-                <a:close/>
-                <a:lnTo>
-                  <a:pt x="1419686" y="348126"/>
-                </a:lnTo>
-                <a:close/>
-                <a:lnTo>
-                  <a:pt x="1424266" y="346568"/>
-                </a:lnTo>
-                <a:close/>
-                <a:lnTo>
-                  <a:pt x="1428845" y="345017"/>
-                </a:lnTo>
-                <a:close/>
-                <a:lnTo>
-                  <a:pt x="1433425" y="343466"/>
-                </a:lnTo>
-                <a:close/>
-                <a:lnTo>
-                  <a:pt x="1438005" y="341912"/>
-                </a:lnTo>
-                <a:close/>
-                <a:lnTo>
-                  <a:pt x="1442584" y="340349"/>
-                </a:lnTo>
-                <a:close/>
-                <a:lnTo>
-                  <a:pt x="1447164" y="338771"/>
-                </a:lnTo>
-                <a:close/>
-                <a:lnTo>
-                  <a:pt x="1451744" y="337174"/>
-                </a:lnTo>
-                <a:close/>
-                <a:lnTo>
-                  <a:pt x="1456323" y="335551"/>
-                </a:lnTo>
-                <a:close/>
-                <a:lnTo>
-                  <a:pt x="1460903" y="333899"/>
-                </a:lnTo>
-                <a:close/>
-                <a:lnTo>
-                  <a:pt x="1465482" y="332211"/>
-                </a:lnTo>
-                <a:close/>
-                <a:lnTo>
-                  <a:pt x="1470062" y="330497"/>
-                </a:lnTo>
-                <a:close/>
-                <a:lnTo>
-                  <a:pt x="1474642" y="328775"/>
-                </a:lnTo>
-                <a:close/>
-                <a:lnTo>
-                  <a:pt x="1479221" y="327064"/>
-                </a:lnTo>
-                <a:close/>
-                <a:lnTo>
-                  <a:pt x="1483801" y="325384"/>
-                </a:lnTo>
-                <a:close/>
-                <a:lnTo>
-                  <a:pt x="1488381" y="323754"/>
-                </a:lnTo>
-                <a:close/>
-                <a:lnTo>
-                  <a:pt x="1492960" y="322194"/>
-                </a:lnTo>
-                <a:close/>
-                <a:lnTo>
-                  <a:pt x="1497540" y="320723"/>
-                </a:lnTo>
-                <a:close/>
-                <a:lnTo>
-                  <a:pt x="1502120" y="319360"/>
-                </a:lnTo>
-                <a:close/>
-                <a:lnTo>
-                  <a:pt x="1506699" y="318125"/>
-                </a:lnTo>
-                <a:close/>
-                <a:lnTo>
-                  <a:pt x="1511279" y="317035"/>
-                </a:lnTo>
-                <a:close/>
-                <a:lnTo>
-                  <a:pt x="1515858" y="316060"/>
-                </a:lnTo>
-                <a:close/>
-                <a:lnTo>
-                  <a:pt x="1520438" y="315128"/>
-                </a:lnTo>
-                <a:close/>
-                <a:lnTo>
-                  <a:pt x="1525018" y="314166"/>
-                </a:lnTo>
-                <a:close/>
-                <a:lnTo>
-                  <a:pt x="1529597" y="313103"/>
-                </a:lnTo>
-                <a:close/>
-                <a:lnTo>
-                  <a:pt x="1534177" y="311865"/>
-                </a:lnTo>
-                <a:close/>
-                <a:lnTo>
-                  <a:pt x="1538757" y="310379"/>
-                </a:lnTo>
-                <a:close/>
-                <a:lnTo>
-                  <a:pt x="1543336" y="308573"/>
-                </a:lnTo>
-                <a:close/>
-                <a:lnTo>
-                  <a:pt x="1547916" y="306374"/>
-                </a:lnTo>
-                <a:close/>
-                <a:lnTo>
-                  <a:pt x="1552495" y="303709"/>
-                </a:lnTo>
-                <a:close/>
-                <a:lnTo>
-                  <a:pt x="1557075" y="300513"/>
-                </a:lnTo>
-                <a:close/>
-                <a:lnTo>
-                  <a:pt x="1561655" y="296821"/>
-                </a:lnTo>
-                <a:close/>
-                <a:lnTo>
-                  <a:pt x="1566234" y="292761"/>
-                </a:lnTo>
-                <a:close/>
-                <a:lnTo>
-                  <a:pt x="1570814" y="288459"/>
-                </a:lnTo>
-                <a:close/>
-                <a:lnTo>
-                  <a:pt x="1575394" y="284045"/>
-                </a:lnTo>
-                <a:close/>
-                <a:lnTo>
-                  <a:pt x="1579973" y="279645"/>
-                </a:lnTo>
-                <a:close/>
-                <a:lnTo>
-                  <a:pt x="1584553" y="275388"/>
-                </a:lnTo>
-                <a:close/>
-                <a:lnTo>
-                  <a:pt x="1589133" y="271402"/>
-                </a:lnTo>
-                <a:close/>
-                <a:lnTo>
-                  <a:pt x="1593712" y="267815"/>
-                </a:lnTo>
-                <a:close/>
-                <a:lnTo>
-                  <a:pt x="1598292" y="264756"/>
-                </a:lnTo>
-                <a:close/>
-                <a:lnTo>
-                  <a:pt x="1602871" y="262344"/>
-                </a:lnTo>
-                <a:close/>
-                <a:lnTo>
-                  <a:pt x="1607451" y="260579"/>
-                </a:lnTo>
-                <a:close/>
-                <a:lnTo>
-                  <a:pt x="1612031" y="259362"/>
-                </a:lnTo>
-                <a:close/>
-                <a:lnTo>
-                  <a:pt x="1616610" y="258593"/>
-                </a:lnTo>
-                <a:close/>
-                <a:lnTo>
-                  <a:pt x="1621190" y="258172"/>
-                </a:lnTo>
-                <a:close/>
-                <a:lnTo>
-                  <a:pt x="1625770" y="257996"/>
-                </a:lnTo>
-                <a:close/>
-                <a:lnTo>
-                  <a:pt x="1630349" y="257965"/>
-                </a:lnTo>
-                <a:close/>
-                <a:lnTo>
-                  <a:pt x="1634929" y="257978"/>
-                </a:lnTo>
-                <a:close/>
-                <a:lnTo>
-                  <a:pt x="1639509" y="257935"/>
-                </a:lnTo>
-                <a:close/>
-                <a:lnTo>
-                  <a:pt x="1644088" y="257734"/>
-                </a:lnTo>
-                <a:close/>
-                <a:lnTo>
-                  <a:pt x="1648668" y="257279"/>
-                </a:lnTo>
-                <a:close/>
-                <a:lnTo>
-                  <a:pt x="1653247" y="256549"/>
-                </a:lnTo>
-                <a:close/>
-                <a:lnTo>
-                  <a:pt x="1657827" y="255582"/>
-                </a:lnTo>
-                <a:close/>
-                <a:lnTo>
-                  <a:pt x="1662407" y="254415"/>
-                </a:lnTo>
-                <a:close/>
-                <a:lnTo>
-                  <a:pt x="1666986" y="253087"/>
-                </a:lnTo>
-                <a:close/>
-                <a:lnTo>
-                  <a:pt x="1671566" y="251636"/>
-                </a:lnTo>
-                <a:close/>
-                <a:lnTo>
-                  <a:pt x="1676146" y="250100"/>
-                </a:lnTo>
-                <a:close/>
-                <a:lnTo>
-                  <a:pt x="1680725" y="248518"/>
-                </a:lnTo>
-                <a:close/>
-                <a:lnTo>
-                  <a:pt x="1685305" y="246927"/>
-                </a:lnTo>
-                <a:close/>
-                <a:lnTo>
-                  <a:pt x="1689884" y="245367"/>
-                </a:lnTo>
-                <a:close/>
-                <a:lnTo>
-                  <a:pt x="1694464" y="243873"/>
-                </a:lnTo>
-                <a:close/>
-                <a:lnTo>
-                  <a:pt x="1699044" y="242455"/>
-                </a:lnTo>
-                <a:close/>
-                <a:lnTo>
-                  <a:pt x="1703623" y="241103"/>
-                </a:lnTo>
-                <a:close/>
-                <a:lnTo>
-                  <a:pt x="1708203" y="239808"/>
-                </a:lnTo>
-                <a:close/>
-                <a:lnTo>
-                  <a:pt x="1712783" y="238559"/>
-                </a:lnTo>
-                <a:close/>
-                <a:lnTo>
-                  <a:pt x="1717362" y="237346"/>
-                </a:lnTo>
-                <a:close/>
-                <a:lnTo>
-                  <a:pt x="1721942" y="236158"/>
-                </a:lnTo>
-                <a:close/>
-                <a:lnTo>
-                  <a:pt x="1726522" y="234985"/>
-                </a:lnTo>
-                <a:close/>
-                <a:lnTo>
-                  <a:pt x="1731101" y="233818"/>
-                </a:lnTo>
-                <a:close/>
-                <a:lnTo>
-                  <a:pt x="1735681" y="232645"/>
-                </a:lnTo>
-                <a:close/>
-                <a:lnTo>
-                  <a:pt x="1740260" y="231457"/>
-                </a:lnTo>
-                <a:close/>
-                <a:lnTo>
-                  <a:pt x="1744840" y="230253"/>
-                </a:lnTo>
-                <a:close/>
-                <a:lnTo>
-                  <a:pt x="1749420" y="229033"/>
-                </a:lnTo>
-                <a:close/>
-                <a:lnTo>
-                  <a:pt x="1753999" y="227801"/>
-                </a:lnTo>
-                <a:close/>
-                <a:lnTo>
-                  <a:pt x="1758579" y="226560"/>
-                </a:lnTo>
-                <a:close/>
-                <a:lnTo>
-                  <a:pt x="1763159" y="225312"/>
-                </a:lnTo>
-                <a:close/>
-                <a:lnTo>
-                  <a:pt x="1767738" y="224059"/>
-                </a:lnTo>
-                <a:close/>
-                <a:lnTo>
-                  <a:pt x="1772318" y="222805"/>
-                </a:lnTo>
-                <a:close/>
-                <a:lnTo>
-                  <a:pt x="1776897" y="221552"/>
-                </a:lnTo>
-                <a:close/>
-                <a:lnTo>
-                  <a:pt x="1781477" y="220303"/>
-                </a:lnTo>
-                <a:close/>
-                <a:lnTo>
-                  <a:pt x="1786057" y="219060"/>
-                </a:lnTo>
-                <a:close/>
-                <a:lnTo>
-                  <a:pt x="1790636" y="217824"/>
-                </a:lnTo>
-                <a:close/>
-                <a:lnTo>
-                  <a:pt x="1795216" y="216594"/>
-                </a:lnTo>
-                <a:close/>
-                <a:lnTo>
-                  <a:pt x="1799796" y="215369"/>
-                </a:lnTo>
-                <a:close/>
-                <a:lnTo>
-                  <a:pt x="1804375" y="214150"/>
-                </a:lnTo>
-                <a:close/>
-                <a:lnTo>
-                  <a:pt x="1808955" y="212935"/>
-                </a:lnTo>
-                <a:close/>
-                <a:lnTo>
-                  <a:pt x="1813535" y="211723"/>
-                </a:lnTo>
-                <a:close/>
-                <a:lnTo>
-                  <a:pt x="1818114" y="210515"/>
-                </a:lnTo>
-                <a:close/>
-                <a:lnTo>
-                  <a:pt x="1822694" y="209310"/>
-                </a:lnTo>
-                <a:close/>
-                <a:lnTo>
-                  <a:pt x="1827273" y="208107"/>
-                </a:lnTo>
-                <a:close/>
-                <a:lnTo>
-                  <a:pt x="1831853" y="206904"/>
-                </a:lnTo>
-                <a:close/>
-                <a:lnTo>
-                  <a:pt x="1836433" y="205704"/>
-                </a:lnTo>
-                <a:close/>
-                <a:lnTo>
-                  <a:pt x="1841012" y="204504"/>
-                </a:lnTo>
-                <a:close/>
-                <a:lnTo>
-                  <a:pt x="1845592" y="203306"/>
-                </a:lnTo>
-                <a:close/>
-                <a:lnTo>
-                  <a:pt x="1850172" y="202109"/>
-                </a:lnTo>
-                <a:close/>
-                <a:lnTo>
-                  <a:pt x="1854751" y="200914"/>
-                </a:lnTo>
-                <a:close/>
-                <a:lnTo>
-                  <a:pt x="1859331" y="199720"/>
-                </a:lnTo>
-                <a:close/>
-                <a:lnTo>
-                  <a:pt x="1863911" y="198528"/>
-                </a:lnTo>
-                <a:close/>
-                <a:lnTo>
-                  <a:pt x="1868490" y="197338"/>
-                </a:lnTo>
-                <a:close/>
-                <a:lnTo>
-                  <a:pt x="1873070" y="196149"/>
-                </a:lnTo>
-                <a:close/>
-                <a:lnTo>
-                  <a:pt x="1877649" y="194962"/>
-                </a:lnTo>
-                <a:close/>
-                <a:lnTo>
-                  <a:pt x="1882229" y="193777"/>
-                </a:lnTo>
-                <a:close/>
-                <a:lnTo>
-                  <a:pt x="1886809" y="192594"/>
-                </a:lnTo>
-                <a:close/>
-                <a:lnTo>
-                  <a:pt x="1891388" y="191413"/>
-                </a:lnTo>
-                <a:close/>
-                <a:lnTo>
-                  <a:pt x="1895968" y="190234"/>
-                </a:lnTo>
-                <a:close/>
-                <a:lnTo>
-                  <a:pt x="1900548" y="189057"/>
-                </a:lnTo>
-                <a:close/>
-                <a:lnTo>
-                  <a:pt x="1905127" y="187882"/>
-                </a:lnTo>
-                <a:close/>
-                <a:lnTo>
-                  <a:pt x="1909707" y="186710"/>
-                </a:lnTo>
-                <a:close/>
-                <a:lnTo>
-                  <a:pt x="1914286" y="185540"/>
-                </a:lnTo>
-                <a:close/>
-                <a:lnTo>
-                  <a:pt x="1918866" y="184373"/>
-                </a:lnTo>
-                <a:close/>
-                <a:lnTo>
-                  <a:pt x="1923446" y="183208"/>
-                </a:lnTo>
-                <a:close/>
-                <a:lnTo>
-                  <a:pt x="1928025" y="182045"/>
-                </a:lnTo>
-                <a:close/>
-                <a:lnTo>
-                  <a:pt x="1932605" y="180885"/>
-                </a:lnTo>
-                <a:close/>
-                <a:lnTo>
-                  <a:pt x="1937185" y="179727"/>
-                </a:lnTo>
-                <a:close/>
-                <a:lnTo>
-                  <a:pt x="1941764" y="178571"/>
-                </a:lnTo>
-                <a:close/>
-                <a:lnTo>
-                  <a:pt x="1946344" y="177418"/>
-                </a:lnTo>
-                <a:close/>
-                <a:lnTo>
-                  <a:pt x="1950924" y="176267"/>
-                </a:lnTo>
-                <a:close/>
-                <a:lnTo>
-                  <a:pt x="1955503" y="175118"/>
-                </a:lnTo>
-                <a:close/>
-                <a:lnTo>
-                  <a:pt x="1960083" y="173971"/>
-                </a:lnTo>
-                <a:close/>
-                <a:lnTo>
-                  <a:pt x="1964662" y="172825"/>
-                </a:lnTo>
-                <a:close/>
-                <a:lnTo>
-                  <a:pt x="1969242" y="171682"/>
-                </a:lnTo>
-                <a:close/>
-                <a:lnTo>
-                  <a:pt x="1973822" y="170541"/>
-                </a:lnTo>
-                <a:close/>
-                <a:lnTo>
-                  <a:pt x="1978401" y="169401"/>
-                </a:lnTo>
-                <a:close/>
-                <a:lnTo>
-                  <a:pt x="1982981" y="168263"/>
-                </a:lnTo>
-                <a:close/>
-                <a:lnTo>
-                  <a:pt x="1987561" y="167126"/>
-                </a:lnTo>
-                <a:close/>
-                <a:lnTo>
-                  <a:pt x="1992140" y="165991"/>
-                </a:lnTo>
-                <a:close/>
-                <a:lnTo>
-                  <a:pt x="1996720" y="164857"/>
-                </a:lnTo>
-                <a:close/>
-                <a:lnTo>
-                  <a:pt x="2001299" y="163725"/>
-                </a:lnTo>
-                <a:close/>
-                <a:lnTo>
-                  <a:pt x="2005879" y="162594"/>
-                </a:lnTo>
-                <a:close/>
-                <a:lnTo>
-                  <a:pt x="2010459" y="161464"/>
-                </a:lnTo>
-                <a:close/>
-                <a:lnTo>
-                  <a:pt x="2015038" y="160335"/>
-                </a:lnTo>
-                <a:close/>
-                <a:lnTo>
-                  <a:pt x="2019618" y="159208"/>
-                </a:lnTo>
-                <a:close/>
-                <a:lnTo>
-                  <a:pt x="2024198" y="158081"/>
-                </a:lnTo>
-                <a:close/>
-                <a:lnTo>
-                  <a:pt x="2028777" y="156956"/>
-                </a:lnTo>
-                <a:close/>
-                <a:lnTo>
-                  <a:pt x="2033357" y="155833"/>
-                </a:lnTo>
-                <a:close/>
-                <a:lnTo>
-                  <a:pt x="2037937" y="154711"/>
-                </a:lnTo>
-                <a:close/>
-                <a:lnTo>
-                  <a:pt x="2042516" y="153590"/>
-                </a:lnTo>
-                <a:close/>
-                <a:lnTo>
-                  <a:pt x="2047096" y="152472"/>
-                </a:lnTo>
-                <a:close/>
-                <a:lnTo>
-                  <a:pt x="2051675" y="151355"/>
-                </a:lnTo>
-                <a:close/>
-                <a:lnTo>
-                  <a:pt x="2056255" y="150240"/>
-                </a:lnTo>
-                <a:close/>
-                <a:lnTo>
-                  <a:pt x="2060835" y="149127"/>
-                </a:lnTo>
-                <a:close/>
-                <a:lnTo>
-                  <a:pt x="2065414" y="148016"/>
-                </a:lnTo>
-                <a:close/>
-                <a:lnTo>
-                  <a:pt x="2069994" y="146907"/>
-                </a:lnTo>
-                <a:close/>
-                <a:lnTo>
-                  <a:pt x="2074574" y="145800"/>
-                </a:lnTo>
-                <a:close/>
-                <a:lnTo>
-                  <a:pt x="2079153" y="144694"/>
-                </a:lnTo>
-                <a:close/>
-                <a:lnTo>
-                  <a:pt x="2083733" y="143591"/>
-                </a:lnTo>
-                <a:close/>
-                <a:lnTo>
-                  <a:pt x="2088313" y="142490"/>
-                </a:lnTo>
-                <a:close/>
-                <a:lnTo>
-                  <a:pt x="2092892" y="141391"/>
-                </a:lnTo>
-                <a:close/>
-                <a:lnTo>
-                  <a:pt x="2097472" y="140294"/>
-                </a:lnTo>
-                <a:close/>
-                <a:lnTo>
-                  <a:pt x="2102051" y="139198"/>
-                </a:lnTo>
-                <a:close/>
-                <a:lnTo>
-                  <a:pt x="2106631" y="138105"/>
-                </a:lnTo>
-                <a:close/>
-                <a:lnTo>
-                  <a:pt x="2111211" y="137013"/>
-                </a:lnTo>
-                <a:close/>
-                <a:lnTo>
-                  <a:pt x="2115790" y="135923"/>
-                </a:lnTo>
-                <a:close/>
-                <a:lnTo>
-                  <a:pt x="2120370" y="134835"/>
-                </a:lnTo>
-                <a:close/>
-                <a:lnTo>
-                  <a:pt x="2124950" y="133749"/>
-                </a:lnTo>
-                <a:close/>
-                <a:lnTo>
-                  <a:pt x="2129529" y="132665"/>
-                </a:lnTo>
-                <a:close/>
-                <a:lnTo>
-                  <a:pt x="2134109" y="131581"/>
-                </a:lnTo>
-                <a:close/>
-                <a:lnTo>
-                  <a:pt x="2138688" y="130500"/>
-                </a:lnTo>
-                <a:close/>
-                <a:lnTo>
-                  <a:pt x="2143268" y="129420"/>
-                </a:lnTo>
-                <a:close/>
-                <a:lnTo>
-                  <a:pt x="2147848" y="128341"/>
-                </a:lnTo>
-                <a:close/>
-                <a:lnTo>
-                  <a:pt x="2152427" y="127263"/>
-                </a:lnTo>
-                <a:close/>
-                <a:lnTo>
-                  <a:pt x="2157007" y="126187"/>
-                </a:lnTo>
-                <a:close/>
-                <a:lnTo>
-                  <a:pt x="2161587" y="125112"/>
-                </a:lnTo>
-                <a:close/>
-                <a:lnTo>
-                  <a:pt x="2166166" y="124038"/>
-                </a:lnTo>
-                <a:close/>
-                <a:lnTo>
-                  <a:pt x="2170746" y="122966"/>
-                </a:lnTo>
-                <a:close/>
-                <a:lnTo>
-                  <a:pt x="2175326" y="121895"/>
-                </a:lnTo>
-                <a:close/>
-                <a:lnTo>
-                  <a:pt x="2179905" y="120825"/>
-                </a:lnTo>
-                <a:close/>
-                <a:lnTo>
-                  <a:pt x="2184485" y="119756"/>
-                </a:lnTo>
-                <a:close/>
-                <a:lnTo>
-                  <a:pt x="2189064" y="118688"/>
-                </a:lnTo>
-                <a:close/>
-                <a:lnTo>
-                  <a:pt x="2193644" y="117622"/>
-                </a:lnTo>
-                <a:close/>
-                <a:lnTo>
-                  <a:pt x="2198224" y="116557"/>
-                </a:lnTo>
-                <a:close/>
-                <a:lnTo>
-                  <a:pt x="2202803" y="115493"/>
-                </a:lnTo>
-                <a:close/>
-                <a:lnTo>
-                  <a:pt x="2207383" y="114430"/>
-                </a:lnTo>
-                <a:close/>
-                <a:lnTo>
-                  <a:pt x="2211963" y="113369"/>
-                </a:lnTo>
-                <a:close/>
-                <a:lnTo>
-                  <a:pt x="2216542" y="112310"/>
-                </a:lnTo>
-                <a:close/>
-                <a:lnTo>
-                  <a:pt x="2221122" y="111252"/>
-                </a:lnTo>
-                <a:close/>
-                <a:lnTo>
-                  <a:pt x="2225702" y="110196"/>
-                </a:lnTo>
-                <a:close/>
-                <a:lnTo>
-                  <a:pt x="2230281" y="109142"/>
-                </a:lnTo>
-                <a:close/>
-                <a:lnTo>
-                  <a:pt x="2234861" y="108090"/>
-                </a:lnTo>
-                <a:close/>
-                <a:lnTo>
-                  <a:pt x="2239440" y="107040"/>
-                </a:lnTo>
-                <a:close/>
-                <a:lnTo>
-                  <a:pt x="2244020" y="105992"/>
-                </a:lnTo>
-                <a:close/>
-                <a:lnTo>
-                  <a:pt x="2248600" y="104946"/>
-                </a:lnTo>
-                <a:close/>
-                <a:lnTo>
-                  <a:pt x="2253179" y="103902"/>
-                </a:lnTo>
-                <a:close/>
-                <a:lnTo>
-                  <a:pt x="2257759" y="102860"/>
-                </a:lnTo>
-                <a:close/>
-                <a:lnTo>
-                  <a:pt x="2262339" y="101819"/>
-                </a:lnTo>
-                <a:close/>
-                <a:lnTo>
-                  <a:pt x="2266918" y="100781"/>
-                </a:lnTo>
-                <a:close/>
-                <a:lnTo>
-                  <a:pt x="2271498" y="99744"/>
-                </a:lnTo>
-                <a:close/>
-                <a:lnTo>
-                  <a:pt x="2276077" y="98708"/>
-                </a:lnTo>
-                <a:close/>
-                <a:lnTo>
-                  <a:pt x="2280657" y="97674"/>
-                </a:lnTo>
-                <a:close/>
-                <a:lnTo>
-                  <a:pt x="2285237" y="96641"/>
-                </a:lnTo>
-                <a:close/>
-                <a:lnTo>
-                  <a:pt x="2289816" y="95609"/>
-                </a:lnTo>
-                <a:close/>
-                <a:lnTo>
-                  <a:pt x="2294396" y="94579"/>
-                </a:lnTo>
-                <a:close/>
-                <a:lnTo>
-                  <a:pt x="2298976" y="93549"/>
-                </a:lnTo>
-                <a:close/>
-                <a:lnTo>
-                  <a:pt x="2303555" y="92521"/>
-                </a:lnTo>
-                <a:close/>
-                <a:lnTo>
-                  <a:pt x="2308135" y="91495"/>
-                </a:lnTo>
-                <a:close/>
-                <a:lnTo>
-                  <a:pt x="2312715" y="90469"/>
-                </a:lnTo>
-                <a:close/>
-                <a:lnTo>
-                  <a:pt x="2317294" y="89445"/>
-                </a:lnTo>
-                <a:close/>
-                <a:lnTo>
-                  <a:pt x="2321874" y="88422"/>
-                </a:lnTo>
-                <a:close/>
-                <a:lnTo>
-                  <a:pt x="2326453" y="87401"/>
-                </a:lnTo>
-                <a:close/>
-                <a:lnTo>
-                  <a:pt x="2331033" y="86381"/>
-                </a:lnTo>
-                <a:close/>
-                <a:lnTo>
-                  <a:pt x="2335613" y="85362"/>
-                </a:lnTo>
-                <a:close/>
-                <a:lnTo>
-                  <a:pt x="2340192" y="84345"/>
-                </a:lnTo>
-                <a:close/>
-                <a:lnTo>
-                  <a:pt x="2344772" y="83329"/>
-                </a:lnTo>
-                <a:close/>
-                <a:lnTo>
-                  <a:pt x="2349352" y="82315"/>
-                </a:lnTo>
-                <a:close/>
-                <a:lnTo>
-                  <a:pt x="2353931" y="81302"/>
-                </a:lnTo>
-                <a:close/>
-                <a:lnTo>
-                  <a:pt x="2358511" y="80290"/>
-                </a:lnTo>
-                <a:close/>
-                <a:lnTo>
-                  <a:pt x="2363090" y="79280"/>
-                </a:lnTo>
-                <a:close/>
-                <a:lnTo>
-                  <a:pt x="2367670" y="78271"/>
-                </a:lnTo>
-                <a:close/>
-                <a:lnTo>
-                  <a:pt x="2372250" y="77264"/>
-                </a:lnTo>
-                <a:close/>
-                <a:lnTo>
-                  <a:pt x="2376829" y="76258"/>
-                </a:lnTo>
-                <a:close/>
-                <a:lnTo>
-                  <a:pt x="2381409" y="75253"/>
-                </a:lnTo>
-                <a:close/>
-                <a:lnTo>
-                  <a:pt x="2385989" y="74250"/>
-                </a:lnTo>
-                <a:close/>
-                <a:lnTo>
-                  <a:pt x="2390568" y="73248"/>
-                </a:lnTo>
-                <a:close/>
-                <a:lnTo>
-                  <a:pt x="2395148" y="72247"/>
-                </a:lnTo>
-                <a:close/>
-                <a:lnTo>
-                  <a:pt x="2399728" y="71248"/>
-                </a:lnTo>
-                <a:close/>
-                <a:lnTo>
-                  <a:pt x="2404307" y="70250"/>
-                </a:lnTo>
-                <a:close/>
-                <a:lnTo>
-                  <a:pt x="2408887" y="69253"/>
-                </a:lnTo>
-                <a:close/>
-                <a:lnTo>
-                  <a:pt x="2413466" y="68258"/>
-                </a:lnTo>
-                <a:close/>
-                <a:lnTo>
-                  <a:pt x="2418046" y="67265"/>
-                </a:lnTo>
-                <a:close/>
-                <a:lnTo>
-                  <a:pt x="2422626" y="66272"/>
-                </a:lnTo>
-                <a:close/>
-                <a:lnTo>
-                  <a:pt x="2427205" y="65281"/>
-                </a:lnTo>
-                <a:close/>
-                <a:lnTo>
-                  <a:pt x="2431785" y="64292"/>
-                </a:lnTo>
-                <a:close/>
-                <a:lnTo>
-                  <a:pt x="2436365" y="63304"/>
-                </a:lnTo>
-                <a:close/>
-                <a:lnTo>
-                  <a:pt x="2440944" y="62317"/>
-                </a:lnTo>
-                <a:close/>
-                <a:lnTo>
-                  <a:pt x="2445524" y="61331"/>
-                </a:lnTo>
-                <a:close/>
-                <a:lnTo>
-                  <a:pt x="2450104" y="60347"/>
-                </a:lnTo>
-                <a:close/>
-                <a:lnTo>
-                  <a:pt x="2454683" y="59365"/>
-                </a:lnTo>
-                <a:close/>
-                <a:lnTo>
-                  <a:pt x="2459263" y="58383"/>
-                </a:lnTo>
-                <a:close/>
-                <a:lnTo>
-                  <a:pt x="2463842" y="57403"/>
-                </a:lnTo>
-                <a:close/>
-                <a:lnTo>
-                  <a:pt x="2468422" y="56425"/>
-                </a:lnTo>
-                <a:close/>
-                <a:lnTo>
-                  <a:pt x="2473002" y="55447"/>
-                </a:lnTo>
-                <a:close/>
-                <a:lnTo>
-                  <a:pt x="2477581" y="54471"/>
-                </a:lnTo>
-                <a:close/>
-                <a:lnTo>
-                  <a:pt x="2482161" y="53497"/>
-                </a:lnTo>
-                <a:close/>
-                <a:lnTo>
-                  <a:pt x="2486741" y="52523"/>
-                </a:lnTo>
-                <a:close/>
-                <a:lnTo>
-                  <a:pt x="2491320" y="51551"/>
-                </a:lnTo>
-                <a:close/>
-                <a:lnTo>
-                  <a:pt x="2495900" y="50581"/>
-                </a:lnTo>
-                <a:close/>
-                <a:lnTo>
-                  <a:pt x="2500479" y="49612"/>
-                </a:lnTo>
-                <a:close/>
-                <a:lnTo>
-                  <a:pt x="2505059" y="48645"/>
-                </a:lnTo>
-                <a:close/>
-                <a:lnTo>
-                  <a:pt x="2509639" y="47679"/>
-                </a:lnTo>
-                <a:close/>
-                <a:lnTo>
-                  <a:pt x="2514218" y="46714"/>
-                </a:lnTo>
-                <a:close/>
-                <a:lnTo>
-                  <a:pt x="2518798" y="45752"/>
-                </a:lnTo>
-                <a:close/>
-                <a:lnTo>
-                  <a:pt x="2523378" y="44790"/>
-                </a:lnTo>
-                <a:close/>
-                <a:lnTo>
-                  <a:pt x="2527957" y="43831"/>
-                </a:lnTo>
-                <a:close/>
-                <a:lnTo>
-                  <a:pt x="2532537" y="42872"/>
-                </a:lnTo>
-                <a:close/>
-                <a:lnTo>
-                  <a:pt x="2537117" y="41915"/>
-                </a:lnTo>
-                <a:close/>
-                <a:lnTo>
-                  <a:pt x="2541696" y="40958"/>
-                </a:lnTo>
-                <a:close/>
-                <a:lnTo>
-                  <a:pt x="2546276" y="40003"/>
-                </a:lnTo>
-                <a:close/>
-                <a:lnTo>
-                  <a:pt x="2550855" y="39049"/>
-                </a:lnTo>
-                <a:close/>
-                <a:lnTo>
-                  <a:pt x="2555435" y="38095"/>
-                </a:lnTo>
-                <a:close/>
-                <a:lnTo>
-                  <a:pt x="2560015" y="37142"/>
-                </a:lnTo>
-                <a:close/>
-                <a:lnTo>
-                  <a:pt x="2564594" y="36190"/>
-                </a:lnTo>
-                <a:close/>
-                <a:lnTo>
-                  <a:pt x="2569174" y="35238"/>
-                </a:lnTo>
-                <a:close/>
-                <a:lnTo>
-                  <a:pt x="2573754" y="34288"/>
-                </a:lnTo>
-                <a:close/>
-                <a:lnTo>
-                  <a:pt x="2578333" y="33338"/>
-                </a:lnTo>
-                <a:close/>
-                <a:lnTo>
-                  <a:pt x="2582913" y="32389"/>
-                </a:lnTo>
-                <a:close/>
-                <a:lnTo>
-                  <a:pt x="2587492" y="31441"/>
-                </a:lnTo>
-                <a:close/>
-                <a:lnTo>
-                  <a:pt x="2592072" y="30494"/>
-                </a:lnTo>
-                <a:close/>
-                <a:lnTo>
-                  <a:pt x="2596652" y="29549"/>
-                </a:lnTo>
-                <a:close/>
-                <a:lnTo>
-                  <a:pt x="2601231" y="28604"/>
-                </a:lnTo>
-                <a:close/>
-                <a:lnTo>
-                  <a:pt x="2605811" y="27662"/>
-                </a:lnTo>
-                <a:close/>
-                <a:lnTo>
-                  <a:pt x="2610391" y="26721"/>
-                </a:lnTo>
-                <a:close/>
-                <a:lnTo>
-                  <a:pt x="2614970" y="25781"/>
-                </a:lnTo>
-                <a:close/>
-                <a:lnTo>
-                  <a:pt x="2619550" y="24843"/>
-                </a:lnTo>
-                <a:close/>
-                <a:lnTo>
-                  <a:pt x="2624130" y="23906"/>
-                </a:lnTo>
-                <a:close/>
-                <a:lnTo>
-                  <a:pt x="2628709" y="22971"/>
-                </a:lnTo>
-                <a:close/>
-                <a:lnTo>
-                  <a:pt x="2633289" y="22038"/>
-                </a:lnTo>
-                <a:close/>
-                <a:lnTo>
-                  <a:pt x="2637868" y="21106"/>
-                </a:lnTo>
-                <a:close/>
-                <a:lnTo>
-                  <a:pt x="2642448" y="20175"/>
-                </a:lnTo>
-                <a:close/>
-                <a:lnTo>
-                  <a:pt x="2647028" y="19246"/>
-                </a:lnTo>
-                <a:close/>
-                <a:lnTo>
-                  <a:pt x="2651607" y="18319"/>
-                </a:lnTo>
-                <a:close/>
-                <a:lnTo>
-                  <a:pt x="2656187" y="17392"/>
-                </a:lnTo>
-                <a:close/>
-                <a:lnTo>
-                  <a:pt x="2660767" y="16468"/>
-                </a:lnTo>
-                <a:close/>
-                <a:lnTo>
-                  <a:pt x="2665346" y="15544"/>
-                </a:lnTo>
-                <a:close/>
-                <a:lnTo>
-                  <a:pt x="2669926" y="14622"/>
-                </a:lnTo>
-                <a:close/>
-                <a:lnTo>
-                  <a:pt x="2674506" y="13701"/>
-                </a:lnTo>
-                <a:close/>
-                <a:lnTo>
-                  <a:pt x="2679085" y="12781"/>
-                </a:lnTo>
-                <a:close/>
-                <a:lnTo>
-                  <a:pt x="2683665" y="11863"/>
-                </a:lnTo>
-                <a:close/>
-                <a:lnTo>
-                  <a:pt x="2688244" y="10945"/>
-                </a:lnTo>
-                <a:close/>
-                <a:lnTo>
-                  <a:pt x="2692824" y="10029"/>
-                </a:lnTo>
-                <a:close/>
-                <a:lnTo>
-                  <a:pt x="2697404" y="9113"/>
-                </a:lnTo>
-                <a:close/>
-                <a:lnTo>
-                  <a:pt x="2701983" y="8199"/>
-                </a:lnTo>
-                <a:close/>
-                <a:lnTo>
-                  <a:pt x="2706563" y="7285"/>
-                </a:lnTo>
-                <a:close/>
-                <a:lnTo>
-                  <a:pt x="2711143" y="6372"/>
-                </a:lnTo>
-                <a:close/>
-                <a:lnTo>
-                  <a:pt x="2715722" y="5460"/>
-                </a:lnTo>
-                <a:close/>
-                <a:lnTo>
-                  <a:pt x="2720302" y="4548"/>
-                </a:lnTo>
-                <a:close/>
-                <a:lnTo>
-                  <a:pt x="2724881" y="3638"/>
-                </a:lnTo>
-                <a:close/>
-                <a:lnTo>
-                  <a:pt x="2729461" y="2727"/>
-                </a:lnTo>
-                <a:close/>
-                <a:lnTo>
-                  <a:pt x="2734041" y="1818"/>
-                </a:lnTo>
-                <a:close/>
-                <a:lnTo>
-                  <a:pt x="2738620" y="908"/>
-                </a:lnTo>
-                <a:close/>
-                <a:lnTo>
-                  <a:pt x="2743200" y="0"/>
+                  <a:pt x="12" y="817298"/>
+                </a:lnTo>
+                <a:close/>
+                <a:lnTo>
+                  <a:pt x="47" y="815401"/>
+                </a:lnTo>
+                <a:close/>
+                <a:lnTo>
+                  <a:pt x="107" y="813520"/>
+                </a:lnTo>
+                <a:close/>
+                <a:lnTo>
+                  <a:pt x="189" y="811651"/>
+                </a:lnTo>
+                <a:close/>
+                <a:lnTo>
+                  <a:pt x="296" y="809792"/>
+                </a:lnTo>
+                <a:close/>
+                <a:lnTo>
+                  <a:pt x="426" y="807943"/>
+                </a:lnTo>
+                <a:close/>
+                <a:lnTo>
+                  <a:pt x="580" y="806099"/>
+                </a:lnTo>
+                <a:close/>
+                <a:lnTo>
+                  <a:pt x="758" y="804261"/>
+                </a:lnTo>
+                <a:close/>
+                <a:lnTo>
+                  <a:pt x="959" y="802425"/>
+                </a:lnTo>
+                <a:close/>
+                <a:lnTo>
+                  <a:pt x="1184" y="800589"/>
+                </a:lnTo>
+                <a:close/>
+                <a:lnTo>
+                  <a:pt x="1433" y="798752"/>
+                </a:lnTo>
+                <a:close/>
+                <a:lnTo>
+                  <a:pt x="1705" y="796911"/>
+                </a:lnTo>
+                <a:close/>
+                <a:lnTo>
+                  <a:pt x="2001" y="795065"/>
+                </a:lnTo>
+                <a:close/>
+                <a:lnTo>
+                  <a:pt x="2321" y="793210"/>
+                </a:lnTo>
+                <a:close/>
+                <a:lnTo>
+                  <a:pt x="2664" y="791348"/>
+                </a:lnTo>
+                <a:close/>
+                <a:lnTo>
+                  <a:pt x="3031" y="789481"/>
+                </a:lnTo>
+                <a:close/>
+                <a:lnTo>
+                  <a:pt x="3422" y="787610"/>
+                </a:lnTo>
+                <a:close/>
+                <a:lnTo>
+                  <a:pt x="3837" y="785738"/>
+                </a:lnTo>
+                <a:close/>
+                <a:lnTo>
+                  <a:pt x="4275" y="783867"/>
+                </a:lnTo>
+                <a:close/>
+                <a:lnTo>
+                  <a:pt x="4737" y="782001"/>
+                </a:lnTo>
+                <a:close/>
+                <a:lnTo>
+                  <a:pt x="5222" y="780140"/>
+                </a:lnTo>
+                <a:close/>
+                <a:lnTo>
+                  <a:pt x="5731" y="778285"/>
+                </a:lnTo>
+                <a:close/>
+                <a:lnTo>
+                  <a:pt x="6264" y="776434"/>
+                </a:lnTo>
+                <a:close/>
+                <a:lnTo>
+                  <a:pt x="6821" y="774585"/>
+                </a:lnTo>
+                <a:close/>
+                <a:lnTo>
+                  <a:pt x="7401" y="772734"/>
+                </a:lnTo>
+                <a:close/>
+                <a:lnTo>
+                  <a:pt x="8005" y="770881"/>
+                </a:lnTo>
+                <a:close/>
+                <a:lnTo>
+                  <a:pt x="8632" y="769022"/>
+                </a:lnTo>
+                <a:close/>
+                <a:lnTo>
+                  <a:pt x="9284" y="767157"/>
+                </a:lnTo>
+                <a:close/>
+                <a:lnTo>
+                  <a:pt x="9959" y="765285"/>
+                </a:lnTo>
+                <a:close/>
+                <a:lnTo>
+                  <a:pt x="10657" y="763408"/>
+                </a:lnTo>
+                <a:close/>
+                <a:lnTo>
+                  <a:pt x="11379" y="761530"/>
+                </a:lnTo>
+                <a:close/>
+                <a:lnTo>
+                  <a:pt x="12125" y="759653"/>
+                </a:lnTo>
+                <a:close/>
+                <a:lnTo>
+                  <a:pt x="12895" y="757777"/>
+                </a:lnTo>
+                <a:close/>
+                <a:lnTo>
+                  <a:pt x="13689" y="755907"/>
+                </a:lnTo>
+                <a:close/>
+                <a:lnTo>
+                  <a:pt x="14506" y="754043"/>
+                </a:lnTo>
+                <a:close/>
+                <a:lnTo>
+                  <a:pt x="15346" y="752185"/>
+                </a:lnTo>
+                <a:close/>
+                <a:lnTo>
+                  <a:pt x="16211" y="750334"/>
+                </a:lnTo>
+                <a:close/>
+                <a:lnTo>
+                  <a:pt x="17099" y="748488"/>
+                </a:lnTo>
+                <a:close/>
+                <a:lnTo>
+                  <a:pt x="18011" y="746647"/>
+                </a:lnTo>
+                <a:close/>
+                <a:lnTo>
+                  <a:pt x="18946" y="744811"/>
+                </a:lnTo>
+                <a:close/>
+                <a:lnTo>
+                  <a:pt x="19905" y="742979"/>
+                </a:lnTo>
+                <a:close/>
+                <a:lnTo>
+                  <a:pt x="20888" y="741151"/>
+                </a:lnTo>
+                <a:close/>
+                <a:lnTo>
+                  <a:pt x="21895" y="739326"/>
+                </a:lnTo>
+                <a:close/>
+                <a:lnTo>
+                  <a:pt x="22925" y="737505"/>
+                </a:lnTo>
+                <a:close/>
+                <a:lnTo>
+                  <a:pt x="23979" y="735686"/>
+                </a:lnTo>
+                <a:close/>
+                <a:lnTo>
+                  <a:pt x="25056" y="733869"/>
+                </a:lnTo>
+                <a:close/>
+                <a:lnTo>
+                  <a:pt x="26157" y="732055"/>
+                </a:lnTo>
+                <a:close/>
+                <a:lnTo>
+                  <a:pt x="27282" y="730241"/>
+                </a:lnTo>
+                <a:close/>
+                <a:lnTo>
+                  <a:pt x="28431" y="728430"/>
+                </a:lnTo>
+                <a:close/>
+                <a:lnTo>
+                  <a:pt x="29603" y="726619"/>
+                </a:lnTo>
+                <a:close/>
+                <a:lnTo>
+                  <a:pt x="30799" y="724811"/>
+                </a:lnTo>
+                <a:close/>
+                <a:lnTo>
+                  <a:pt x="32019" y="723005"/>
+                </a:lnTo>
+                <a:close/>
+                <a:lnTo>
+                  <a:pt x="33262" y="721201"/>
+                </a:lnTo>
+                <a:close/>
+                <a:lnTo>
+                  <a:pt x="34529" y="719399"/>
+                </a:lnTo>
+                <a:close/>
+                <a:lnTo>
+                  <a:pt x="35820" y="717601"/>
+                </a:lnTo>
+                <a:close/>
+                <a:lnTo>
+                  <a:pt x="37134" y="715805"/>
+                </a:lnTo>
+                <a:close/>
+                <a:lnTo>
+                  <a:pt x="38472" y="714013"/>
+                </a:lnTo>
+                <a:close/>
+                <a:lnTo>
+                  <a:pt x="39834" y="712225"/>
+                </a:lnTo>
+                <a:close/>
+                <a:lnTo>
+                  <a:pt x="41220" y="710440"/>
+                </a:lnTo>
+                <a:close/>
+                <a:lnTo>
+                  <a:pt x="42629" y="708659"/>
+                </a:lnTo>
+                <a:close/>
+                <a:lnTo>
+                  <a:pt x="44061" y="706883"/>
+                </a:lnTo>
+                <a:close/>
+                <a:lnTo>
+                  <a:pt x="45518" y="705112"/>
+                </a:lnTo>
+                <a:close/>
+                <a:lnTo>
+                  <a:pt x="46998" y="703344"/>
+                </a:lnTo>
+                <a:close/>
+                <a:lnTo>
+                  <a:pt x="48502" y="701581"/>
+                </a:lnTo>
+                <a:close/>
+                <a:lnTo>
+                  <a:pt x="50029" y="699821"/>
+                </a:lnTo>
+                <a:close/>
+                <a:lnTo>
+                  <a:pt x="51581" y="698065"/>
+                </a:lnTo>
+                <a:close/>
+                <a:lnTo>
+                  <a:pt x="53156" y="696311"/>
+                </a:lnTo>
+                <a:close/>
+                <a:lnTo>
+                  <a:pt x="54754" y="694560"/>
+                </a:lnTo>
+                <a:close/>
+                <a:lnTo>
+                  <a:pt x="56376" y="692812"/>
+                </a:lnTo>
+                <a:close/>
+                <a:lnTo>
+                  <a:pt x="58022" y="691065"/>
+                </a:lnTo>
+                <a:close/>
+                <a:lnTo>
+                  <a:pt x="59692" y="689322"/>
+                </a:lnTo>
+                <a:close/>
+                <a:lnTo>
+                  <a:pt x="61385" y="687582"/>
+                </a:lnTo>
+                <a:close/>
+                <a:lnTo>
+                  <a:pt x="63102" y="685845"/>
+                </a:lnTo>
+                <a:close/>
+                <a:lnTo>
+                  <a:pt x="64843" y="684112"/>
+                </a:lnTo>
+                <a:close/>
+                <a:lnTo>
+                  <a:pt x="66607" y="682384"/>
+                </a:lnTo>
+                <a:close/>
+                <a:lnTo>
+                  <a:pt x="68395" y="680660"/>
+                </a:lnTo>
+                <a:close/>
+                <a:lnTo>
+                  <a:pt x="70207" y="678940"/>
+                </a:lnTo>
+                <a:close/>
+                <a:lnTo>
+                  <a:pt x="72042" y="677224"/>
+                </a:lnTo>
+                <a:close/>
+                <a:lnTo>
+                  <a:pt x="73902" y="675513"/>
+                </a:lnTo>
+                <a:close/>
+                <a:lnTo>
+                  <a:pt x="75784" y="673805"/>
+                </a:lnTo>
+                <a:close/>
+                <a:lnTo>
+                  <a:pt x="77691" y="672101"/>
+                </a:lnTo>
+                <a:close/>
+                <a:lnTo>
+                  <a:pt x="79621" y="670400"/>
+                </a:lnTo>
+                <a:close/>
+                <a:lnTo>
+                  <a:pt x="81575" y="668703"/>
+                </a:lnTo>
+                <a:close/>
+                <a:lnTo>
+                  <a:pt x="83552" y="667010"/>
+                </a:lnTo>
+                <a:close/>
+                <a:lnTo>
+                  <a:pt x="85553" y="665320"/>
+                </a:lnTo>
+                <a:close/>
+                <a:lnTo>
+                  <a:pt x="87578" y="663636"/>
+                </a:lnTo>
+                <a:close/>
+                <a:lnTo>
+                  <a:pt x="89627" y="661956"/>
+                </a:lnTo>
+                <a:close/>
+                <a:lnTo>
+                  <a:pt x="91699" y="660282"/>
+                </a:lnTo>
+                <a:close/>
+                <a:lnTo>
+                  <a:pt x="93795" y="658613"/>
+                </a:lnTo>
+                <a:close/>
+                <a:lnTo>
+                  <a:pt x="95914" y="656949"/>
+                </a:lnTo>
+                <a:close/>
+                <a:lnTo>
+                  <a:pt x="98058" y="655291"/>
+                </a:lnTo>
+                <a:close/>
+                <a:lnTo>
+                  <a:pt x="100225" y="653638"/>
+                </a:lnTo>
+                <a:close/>
+                <a:lnTo>
+                  <a:pt x="102415" y="651989"/>
+                </a:lnTo>
+                <a:close/>
+                <a:lnTo>
+                  <a:pt x="104630" y="650344"/>
+                </a:lnTo>
+                <a:close/>
+                <a:lnTo>
+                  <a:pt x="106868" y="648703"/>
+                </a:lnTo>
+                <a:close/>
+                <a:lnTo>
+                  <a:pt x="109129" y="647064"/>
+                </a:lnTo>
+                <a:close/>
+                <a:lnTo>
+                  <a:pt x="111415" y="645429"/>
+                </a:lnTo>
+                <a:close/>
+                <a:lnTo>
+                  <a:pt x="113724" y="643798"/>
+                </a:lnTo>
+                <a:close/>
+                <a:lnTo>
+                  <a:pt x="116057" y="642171"/>
+                </a:lnTo>
+                <a:close/>
+                <a:lnTo>
+                  <a:pt x="118413" y="640548"/>
+                </a:lnTo>
+                <a:close/>
+                <a:lnTo>
+                  <a:pt x="120793" y="638931"/>
+                </a:lnTo>
+                <a:close/>
+                <a:lnTo>
+                  <a:pt x="123197" y="637319"/>
+                </a:lnTo>
+                <a:close/>
+                <a:lnTo>
+                  <a:pt x="125624" y="635712"/>
+                </a:lnTo>
+                <a:close/>
+                <a:lnTo>
+                  <a:pt x="128075" y="634111"/>
+                </a:lnTo>
+                <a:close/>
+                <a:lnTo>
+                  <a:pt x="130550" y="632516"/>
+                </a:lnTo>
+                <a:close/>
+                <a:lnTo>
+                  <a:pt x="133049" y="630924"/>
+                </a:lnTo>
+                <a:close/>
+                <a:lnTo>
+                  <a:pt x="135571" y="629338"/>
+                </a:lnTo>
+                <a:close/>
+                <a:lnTo>
+                  <a:pt x="138117" y="627755"/>
+                </a:lnTo>
+                <a:close/>
+                <a:lnTo>
+                  <a:pt x="140686" y="626175"/>
+                </a:lnTo>
+                <a:close/>
+                <a:lnTo>
+                  <a:pt x="143280" y="624598"/>
+                </a:lnTo>
+                <a:close/>
+                <a:lnTo>
+                  <a:pt x="145897" y="623025"/>
+                </a:lnTo>
+                <a:close/>
+                <a:lnTo>
+                  <a:pt x="148537" y="621456"/>
+                </a:lnTo>
+                <a:close/>
+                <a:lnTo>
+                  <a:pt x="151201" y="619891"/>
+                </a:lnTo>
+                <a:close/>
+                <a:lnTo>
+                  <a:pt x="153889" y="618331"/>
+                </a:lnTo>
+                <a:close/>
+                <a:lnTo>
+                  <a:pt x="156601" y="616775"/>
+                </a:lnTo>
+                <a:close/>
+                <a:lnTo>
+                  <a:pt x="159336" y="615226"/>
+                </a:lnTo>
+                <a:close/>
+                <a:lnTo>
+                  <a:pt x="162095" y="613682"/>
+                </a:lnTo>
+                <a:close/>
+                <a:lnTo>
+                  <a:pt x="164878" y="612144"/>
+                </a:lnTo>
+                <a:close/>
+                <a:lnTo>
+                  <a:pt x="167685" y="610610"/>
+                </a:lnTo>
+                <a:close/>
+                <a:lnTo>
+                  <a:pt x="170515" y="609081"/>
+                </a:lnTo>
+                <a:close/>
+                <a:lnTo>
+                  <a:pt x="173368" y="607557"/>
+                </a:lnTo>
+                <a:close/>
+                <a:lnTo>
+                  <a:pt x="176246" y="606035"/>
+                </a:lnTo>
+                <a:close/>
+                <a:lnTo>
+                  <a:pt x="179147" y="604517"/>
+                </a:lnTo>
+                <a:close/>
+                <a:lnTo>
+                  <a:pt x="182072" y="603002"/>
+                </a:lnTo>
+                <a:close/>
+                <a:lnTo>
+                  <a:pt x="185020" y="601491"/>
+                </a:lnTo>
+                <a:close/>
+                <a:lnTo>
+                  <a:pt x="187992" y="599984"/>
+                </a:lnTo>
+                <a:close/>
+                <a:lnTo>
+                  <a:pt x="190988" y="598481"/>
+                </a:lnTo>
+                <a:close/>
+                <a:lnTo>
+                  <a:pt x="194008" y="596983"/>
+                </a:lnTo>
+                <a:close/>
+                <a:lnTo>
+                  <a:pt x="197051" y="595491"/>
+                </a:lnTo>
+                <a:close/>
+                <a:lnTo>
+                  <a:pt x="200118" y="594004"/>
+                </a:lnTo>
+                <a:close/>
+                <a:lnTo>
+                  <a:pt x="203208" y="592523"/>
+                </a:lnTo>
+                <a:close/>
+                <a:lnTo>
+                  <a:pt x="206323" y="591047"/>
+                </a:lnTo>
+                <a:close/>
+                <a:lnTo>
+                  <a:pt x="209461" y="589576"/>
+                </a:lnTo>
+                <a:close/>
+                <a:lnTo>
+                  <a:pt x="212622" y="588109"/>
+                </a:lnTo>
+                <a:close/>
+                <a:lnTo>
+                  <a:pt x="215808" y="586646"/>
+                </a:lnTo>
+                <a:close/>
+                <a:lnTo>
+                  <a:pt x="219017" y="585186"/>
+                </a:lnTo>
+                <a:close/>
+                <a:lnTo>
+                  <a:pt x="222249" y="583730"/>
+                </a:lnTo>
+                <a:close/>
+                <a:lnTo>
+                  <a:pt x="225506" y="582277"/>
+                </a:lnTo>
+                <a:close/>
+                <a:lnTo>
+                  <a:pt x="228786" y="580827"/>
+                </a:lnTo>
+                <a:close/>
+                <a:lnTo>
+                  <a:pt x="232089" y="579382"/>
+                </a:lnTo>
+                <a:close/>
+                <a:lnTo>
+                  <a:pt x="235417" y="577942"/>
+                </a:lnTo>
+                <a:close/>
+                <a:lnTo>
+                  <a:pt x="238768" y="576506"/>
+                </a:lnTo>
+                <a:close/>
+                <a:lnTo>
+                  <a:pt x="242143" y="575077"/>
+                </a:lnTo>
+                <a:close/>
+                <a:lnTo>
+                  <a:pt x="245541" y="573653"/>
+                </a:lnTo>
+                <a:close/>
+                <a:lnTo>
+                  <a:pt x="248963" y="572234"/>
+                </a:lnTo>
+                <a:close/>
+                <a:lnTo>
+                  <a:pt x="252409" y="570821"/>
+                </a:lnTo>
+                <a:close/>
+                <a:lnTo>
+                  <a:pt x="255879" y="569412"/>
+                </a:lnTo>
+                <a:close/>
+                <a:lnTo>
+                  <a:pt x="259372" y="568007"/>
+                </a:lnTo>
+                <a:close/>
+                <a:lnTo>
+                  <a:pt x="262889" y="566606"/>
+                </a:lnTo>
+                <a:close/>
+                <a:lnTo>
+                  <a:pt x="266429" y="565207"/>
+                </a:lnTo>
+                <a:close/>
+                <a:lnTo>
+                  <a:pt x="269993" y="563811"/>
+                </a:lnTo>
+                <a:close/>
+                <a:lnTo>
+                  <a:pt x="273581" y="562419"/>
+                </a:lnTo>
+                <a:close/>
+                <a:lnTo>
+                  <a:pt x="277192" y="561031"/>
+                </a:lnTo>
+                <a:close/>
+                <a:lnTo>
+                  <a:pt x="280827" y="559648"/>
+                </a:lnTo>
+                <a:close/>
+                <a:lnTo>
+                  <a:pt x="284486" y="558270"/>
+                </a:lnTo>
+                <a:close/>
+                <a:lnTo>
+                  <a:pt x="288169" y="556899"/>
+                </a:lnTo>
+                <a:close/>
+                <a:lnTo>
+                  <a:pt x="291876" y="555534"/>
+                </a:lnTo>
+                <a:close/>
+                <a:lnTo>
+                  <a:pt x="295607" y="554176"/>
+                </a:lnTo>
+                <a:close/>
+                <a:lnTo>
+                  <a:pt x="299362" y="552821"/>
+                </a:lnTo>
+                <a:close/>
+                <a:lnTo>
+                  <a:pt x="303140" y="551469"/>
+                </a:lnTo>
+                <a:close/>
+                <a:lnTo>
+                  <a:pt x="306941" y="550115"/>
+                </a:lnTo>
+                <a:close/>
+                <a:lnTo>
+                  <a:pt x="310765" y="548760"/>
+                </a:lnTo>
+                <a:close/>
+                <a:lnTo>
+                  <a:pt x="314612" y="547399"/>
+                </a:lnTo>
+                <a:close/>
+                <a:lnTo>
+                  <a:pt x="318482" y="546032"/>
+                </a:lnTo>
+                <a:close/>
+                <a:lnTo>
+                  <a:pt x="322374" y="544662"/>
+                </a:lnTo>
+                <a:close/>
+                <a:lnTo>
+                  <a:pt x="326291" y="543298"/>
+                </a:lnTo>
+                <a:close/>
+                <a:lnTo>
+                  <a:pt x="330232" y="541947"/>
+                </a:lnTo>
+                <a:close/>
+                <a:lnTo>
+                  <a:pt x="334199" y="540619"/>
+                </a:lnTo>
+                <a:close/>
+                <a:lnTo>
+                  <a:pt x="338192" y="539320"/>
+                </a:lnTo>
+                <a:close/>
+                <a:lnTo>
+                  <a:pt x="342212" y="538060"/>
+                </a:lnTo>
+                <a:close/>
+                <a:lnTo>
+                  <a:pt x="346260" y="536844"/>
+                </a:lnTo>
+                <a:close/>
+                <a:lnTo>
+                  <a:pt x="350333" y="535649"/>
+                </a:lnTo>
+                <a:close/>
+                <a:lnTo>
+                  <a:pt x="354428" y="534447"/>
+                </a:lnTo>
+                <a:close/>
+                <a:lnTo>
+                  <a:pt x="358543" y="533206"/>
+                </a:lnTo>
+                <a:close/>
+                <a:lnTo>
+                  <a:pt x="362675" y="531896"/>
+                </a:lnTo>
+                <a:close/>
+                <a:lnTo>
+                  <a:pt x="366820" y="530485"/>
+                </a:lnTo>
+                <a:close/>
+                <a:lnTo>
+                  <a:pt x="370975" y="528944"/>
+                </a:lnTo>
+                <a:close/>
+                <a:lnTo>
+                  <a:pt x="375140" y="527267"/>
+                </a:lnTo>
+                <a:close/>
+                <a:lnTo>
+                  <a:pt x="379324" y="525547"/>
+                </a:lnTo>
+                <a:close/>
+                <a:lnTo>
+                  <a:pt x="383539" y="523900"/>
+                </a:lnTo>
+                <a:close/>
+                <a:lnTo>
+                  <a:pt x="387795" y="522441"/>
+                </a:lnTo>
+                <a:close/>
+                <a:lnTo>
+                  <a:pt x="392104" y="521285"/>
+                </a:lnTo>
+                <a:close/>
+                <a:lnTo>
+                  <a:pt x="396477" y="520549"/>
+                </a:lnTo>
+                <a:close/>
+                <a:lnTo>
+                  <a:pt x="400926" y="520346"/>
+                </a:lnTo>
+                <a:close/>
+                <a:lnTo>
+                  <a:pt x="405446" y="520631"/>
+                </a:lnTo>
+                <a:close/>
+                <a:lnTo>
+                  <a:pt x="409999" y="521015"/>
+                </a:lnTo>
+                <a:close/>
+                <a:lnTo>
+                  <a:pt x="414543" y="521067"/>
+                </a:lnTo>
+                <a:close/>
+                <a:lnTo>
+                  <a:pt x="419035" y="520356"/>
+                </a:lnTo>
+                <a:close/>
+                <a:lnTo>
+                  <a:pt x="423434" y="518448"/>
+                </a:lnTo>
+                <a:close/>
+                <a:lnTo>
+                  <a:pt x="427696" y="514911"/>
+                </a:lnTo>
+                <a:close/>
+                <a:lnTo>
+                  <a:pt x="431782" y="509328"/>
+                </a:lnTo>
+                <a:close/>
+                <a:lnTo>
+                  <a:pt x="435700" y="501735"/>
+                </a:lnTo>
+                <a:close/>
+                <a:lnTo>
+                  <a:pt x="439524" y="492755"/>
+                </a:lnTo>
+                <a:close/>
+                <a:lnTo>
+                  <a:pt x="443333" y="483045"/>
+                </a:lnTo>
+                <a:close/>
+                <a:lnTo>
+                  <a:pt x="447203" y="473264"/>
+                </a:lnTo>
+                <a:close/>
+                <a:lnTo>
+                  <a:pt x="451213" y="464070"/>
+                </a:lnTo>
+                <a:close/>
+                <a:lnTo>
+                  <a:pt x="455441" y="456120"/>
+                </a:lnTo>
+                <a:close/>
+                <a:lnTo>
+                  <a:pt x="459959" y="450036"/>
+                </a:lnTo>
+                <a:close/>
+                <a:lnTo>
+                  <a:pt x="464765" y="445863"/>
+                </a:lnTo>
+                <a:close/>
+                <a:lnTo>
+                  <a:pt x="469799" y="443213"/>
+                </a:lnTo>
+                <a:close/>
+                <a:lnTo>
+                  <a:pt x="475001" y="441684"/>
+                </a:lnTo>
+                <a:close/>
+                <a:lnTo>
+                  <a:pt x="480309" y="440874"/>
+                </a:lnTo>
+                <a:close/>
+                <a:lnTo>
+                  <a:pt x="485663" y="440382"/>
+                </a:lnTo>
+                <a:close/>
+                <a:lnTo>
+                  <a:pt x="491000" y="439808"/>
+                </a:lnTo>
+                <a:close/>
+                <a:lnTo>
+                  <a:pt x="496267" y="438791"/>
+                </a:lnTo>
+                <a:close/>
+                <a:lnTo>
+                  <a:pt x="501458" y="437295"/>
+                </a:lnTo>
+                <a:close/>
+                <a:lnTo>
+                  <a:pt x="506590" y="435425"/>
+                </a:lnTo>
+                <a:close/>
+                <a:lnTo>
+                  <a:pt x="511680" y="433289"/>
+                </a:lnTo>
+                <a:close/>
+                <a:lnTo>
+                  <a:pt x="516745" y="430996"/>
+                </a:lnTo>
+                <a:close/>
+                <a:lnTo>
+                  <a:pt x="521801" y="428651"/>
+                </a:lnTo>
+                <a:close/>
+                <a:lnTo>
+                  <a:pt x="526865" y="426364"/>
+                </a:lnTo>
+                <a:close/>
+                <a:lnTo>
+                  <a:pt x="531952" y="424220"/>
+                </a:lnTo>
+                <a:close/>
+                <a:lnTo>
+                  <a:pt x="537059" y="422212"/>
+                </a:lnTo>
+                <a:close/>
+                <a:lnTo>
+                  <a:pt x="542183" y="420313"/>
+                </a:lnTo>
+                <a:close/>
+                <a:lnTo>
+                  <a:pt x="547317" y="418493"/>
+                </a:lnTo>
+                <a:close/>
+                <a:lnTo>
+                  <a:pt x="552459" y="416723"/>
+                </a:lnTo>
+                <a:close/>
+                <a:lnTo>
+                  <a:pt x="557602" y="414973"/>
+                </a:lnTo>
+                <a:close/>
+                <a:lnTo>
+                  <a:pt x="562741" y="413216"/>
+                </a:lnTo>
+                <a:close/>
+                <a:lnTo>
+                  <a:pt x="567875" y="411432"/>
+                </a:lnTo>
+                <a:close/>
+                <a:lnTo>
+                  <a:pt x="573003" y="409625"/>
+                </a:lnTo>
+                <a:close/>
+                <a:lnTo>
+                  <a:pt x="578128" y="407803"/>
+                </a:lnTo>
+                <a:close/>
+                <a:lnTo>
+                  <a:pt x="583249" y="405973"/>
+                </a:lnTo>
+                <a:close/>
+                <a:lnTo>
+                  <a:pt x="588370" y="404144"/>
+                </a:lnTo>
+                <a:close/>
+                <a:lnTo>
+                  <a:pt x="593491" y="402324"/>
+                </a:lnTo>
+                <a:close/>
+                <a:lnTo>
+                  <a:pt x="598613" y="400518"/>
+                </a:lnTo>
+                <a:close/>
+                <a:lnTo>
+                  <a:pt x="603737" y="398732"/>
+                </a:lnTo>
+                <a:close/>
+                <a:lnTo>
+                  <a:pt x="608863" y="396963"/>
+                </a:lnTo>
+                <a:close/>
+                <a:lnTo>
+                  <a:pt x="613989" y="395208"/>
+                </a:lnTo>
+                <a:close/>
+                <a:lnTo>
+                  <a:pt x="619115" y="393466"/>
+                </a:lnTo>
+                <a:close/>
+                <a:lnTo>
+                  <a:pt x="624240" y="391732"/>
+                </a:lnTo>
+                <a:close/>
+                <a:lnTo>
+                  <a:pt x="629364" y="390005"/>
+                </a:lnTo>
+                <a:close/>
+                <a:lnTo>
+                  <a:pt x="634486" y="388281"/>
+                </a:lnTo>
+                <a:close/>
+                <a:lnTo>
+                  <a:pt x="639605" y="386562"/>
+                </a:lnTo>
+                <a:close/>
+                <a:lnTo>
+                  <a:pt x="644723" y="384847"/>
+                </a:lnTo>
+                <a:close/>
+                <a:lnTo>
+                  <a:pt x="649840" y="383137"/>
+                </a:lnTo>
+                <a:close/>
+                <a:lnTo>
+                  <a:pt x="654957" y="381433"/>
+                </a:lnTo>
+                <a:close/>
+                <a:lnTo>
+                  <a:pt x="660074" y="379737"/>
+                </a:lnTo>
+                <a:close/>
+                <a:lnTo>
+                  <a:pt x="665193" y="378049"/>
+                </a:lnTo>
+                <a:close/>
+                <a:lnTo>
+                  <a:pt x="670314" y="376370"/>
+                </a:lnTo>
+                <a:close/>
+                <a:lnTo>
+                  <a:pt x="675436" y="374700"/>
+                </a:lnTo>
+                <a:close/>
+                <a:lnTo>
+                  <a:pt x="680560" y="373039"/>
+                </a:lnTo>
+                <a:close/>
+                <a:lnTo>
+                  <a:pt x="685686" y="371386"/>
+                </a:lnTo>
+                <a:close/>
+                <a:lnTo>
+                  <a:pt x="690812" y="369742"/>
+                </a:lnTo>
+                <a:close/>
+                <a:lnTo>
+                  <a:pt x="695939" y="368104"/>
+                </a:lnTo>
+                <a:close/>
+                <a:lnTo>
+                  <a:pt x="701066" y="366474"/>
+                </a:lnTo>
+                <a:close/>
+                <a:lnTo>
+                  <a:pt x="706193" y="364850"/>
+                </a:lnTo>
+                <a:close/>
+                <a:lnTo>
+                  <a:pt x="711320" y="363233"/>
+                </a:lnTo>
+                <a:close/>
+                <a:lnTo>
+                  <a:pt x="716446" y="361622"/>
+                </a:lnTo>
+                <a:close/>
+                <a:lnTo>
+                  <a:pt x="721572" y="360018"/>
+                </a:lnTo>
+                <a:close/>
+                <a:lnTo>
+                  <a:pt x="726696" y="358419"/>
+                </a:lnTo>
+                <a:close/>
+                <a:lnTo>
+                  <a:pt x="731819" y="356826"/>
+                </a:lnTo>
+                <a:close/>
+                <a:lnTo>
+                  <a:pt x="736940" y="355239"/>
+                </a:lnTo>
+                <a:close/>
+                <a:lnTo>
+                  <a:pt x="742059" y="353658"/>
+                </a:lnTo>
+                <a:close/>
+                <a:lnTo>
+                  <a:pt x="747177" y="352082"/>
+                </a:lnTo>
+                <a:close/>
+                <a:lnTo>
+                  <a:pt x="752294" y="350512"/>
+                </a:lnTo>
+                <a:close/>
+                <a:lnTo>
+                  <a:pt x="757411" y="348948"/>
+                </a:lnTo>
+                <a:close/>
+                <a:lnTo>
+                  <a:pt x="762529" y="347391"/>
+                </a:lnTo>
+                <a:close/>
+                <a:lnTo>
+                  <a:pt x="767647" y="345839"/>
+                </a:lnTo>
+                <a:close/>
+                <a:lnTo>
+                  <a:pt x="772768" y="344294"/>
+                </a:lnTo>
+                <a:close/>
+                <a:lnTo>
+                  <a:pt x="777890" y="342756"/>
+                </a:lnTo>
+                <a:close/>
+                <a:lnTo>
+                  <a:pt x="783014" y="341223"/>
+                </a:lnTo>
+                <a:close/>
+                <a:lnTo>
+                  <a:pt x="788140" y="339696"/>
+                </a:lnTo>
+                <a:close/>
+                <a:lnTo>
+                  <a:pt x="793266" y="338174"/>
+                </a:lnTo>
+                <a:close/>
+                <a:lnTo>
+                  <a:pt x="798392" y="336657"/>
+                </a:lnTo>
+                <a:close/>
+                <a:lnTo>
+                  <a:pt x="803518" y="335145"/>
+                </a:lnTo>
+                <a:close/>
+                <a:lnTo>
+                  <a:pt x="808644" y="333637"/>
+                </a:lnTo>
+                <a:close/>
+                <a:lnTo>
+                  <a:pt x="813769" y="332133"/>
+                </a:lnTo>
+                <a:close/>
+                <a:lnTo>
+                  <a:pt x="818894" y="330634"/>
+                </a:lnTo>
+                <a:close/>
+                <a:lnTo>
+                  <a:pt x="824018" y="329141"/>
+                </a:lnTo>
+                <a:close/>
+                <a:lnTo>
+                  <a:pt x="829143" y="327652"/>
+                </a:lnTo>
+                <a:close/>
+                <a:lnTo>
+                  <a:pt x="834268" y="326170"/>
+                </a:lnTo>
+                <a:close/>
+                <a:lnTo>
+                  <a:pt x="839393" y="324693"/>
+                </a:lnTo>
+                <a:close/>
+                <a:lnTo>
+                  <a:pt x="844519" y="323224"/>
+                </a:lnTo>
+                <a:close/>
+                <a:lnTo>
+                  <a:pt x="849645" y="321761"/>
+                </a:lnTo>
+                <a:close/>
+                <a:lnTo>
+                  <a:pt x="854771" y="320304"/>
+                </a:lnTo>
+                <a:close/>
+                <a:lnTo>
+                  <a:pt x="859897" y="318853"/>
+                </a:lnTo>
+                <a:close/>
+                <a:lnTo>
+                  <a:pt x="865022" y="317407"/>
+                </a:lnTo>
+                <a:close/>
+                <a:lnTo>
+                  <a:pt x="870146" y="315966"/>
+                </a:lnTo>
+                <a:close/>
+                <a:lnTo>
+                  <a:pt x="875268" y="314531"/>
+                </a:lnTo>
+                <a:close/>
+                <a:lnTo>
+                  <a:pt x="880388" y="313099"/>
+                </a:lnTo>
+                <a:close/>
+                <a:lnTo>
+                  <a:pt x="885506" y="311672"/>
+                </a:lnTo>
+                <a:close/>
+                <a:lnTo>
+                  <a:pt x="890624" y="310250"/>
+                </a:lnTo>
+                <a:close/>
+                <a:lnTo>
+                  <a:pt x="895741" y="308833"/>
+                </a:lnTo>
+                <a:close/>
+                <a:lnTo>
+                  <a:pt x="900858" y="307420"/>
+                </a:lnTo>
+                <a:close/>
+                <a:lnTo>
+                  <a:pt x="905976" y="306013"/>
+                </a:lnTo>
+                <a:close/>
+                <a:lnTo>
+                  <a:pt x="911096" y="304610"/>
+                </a:lnTo>
+                <a:close/>
+                <a:lnTo>
+                  <a:pt x="916217" y="303214"/>
+                </a:lnTo>
+                <a:close/>
+                <a:lnTo>
+                  <a:pt x="921340" y="301822"/>
+                </a:lnTo>
+                <a:close/>
+                <a:lnTo>
+                  <a:pt x="926465" y="300435"/>
+                </a:lnTo>
+                <a:close/>
+                <a:lnTo>
+                  <a:pt x="931591" y="299053"/>
+                </a:lnTo>
+                <a:close/>
+                <a:lnTo>
+                  <a:pt x="936717" y="297675"/>
+                </a:lnTo>
+                <a:close/>
+                <a:lnTo>
+                  <a:pt x="941844" y="296301"/>
+                </a:lnTo>
+                <a:close/>
+                <a:lnTo>
+                  <a:pt x="946971" y="294931"/>
+                </a:lnTo>
+                <a:close/>
+                <a:lnTo>
+                  <a:pt x="952098" y="293565"/>
+                </a:lnTo>
+                <a:close/>
+                <a:lnTo>
+                  <a:pt x="957225" y="292203"/>
+                </a:lnTo>
+                <a:close/>
+                <a:lnTo>
+                  <a:pt x="962351" y="290844"/>
+                </a:lnTo>
+                <a:close/>
+                <a:lnTo>
+                  <a:pt x="967476" y="289489"/>
+                </a:lnTo>
+                <a:close/>
+                <a:lnTo>
+                  <a:pt x="972600" y="288137"/>
+                </a:lnTo>
+                <a:close/>
+                <a:lnTo>
+                  <a:pt x="977722" y="286789"/>
+                </a:lnTo>
+                <a:close/>
+                <a:lnTo>
+                  <a:pt x="982842" y="285444"/>
+                </a:lnTo>
+                <a:close/>
+                <a:lnTo>
+                  <a:pt x="987961" y="284103"/>
+                </a:lnTo>
+                <a:close/>
+                <a:lnTo>
+                  <a:pt x="993079" y="282766"/>
+                </a:lnTo>
+                <a:close/>
+                <a:lnTo>
+                  <a:pt x="998196" y="281433"/>
+                </a:lnTo>
+                <a:close/>
+                <a:lnTo>
+                  <a:pt x="1003313" y="280106"/>
+                </a:lnTo>
+                <a:close/>
+                <a:lnTo>
+                  <a:pt x="1008431" y="278783"/>
+                </a:lnTo>
+                <a:close/>
+                <a:lnTo>
+                  <a:pt x="1013550" y="277466"/>
+                </a:lnTo>
+                <a:close/>
+                <a:lnTo>
+                  <a:pt x="1018671" y="276155"/>
+                </a:lnTo>
+                <a:close/>
+                <a:lnTo>
+                  <a:pt x="1023794" y="274850"/>
+                </a:lnTo>
+                <a:close/>
+                <a:lnTo>
+                  <a:pt x="1028919" y="273549"/>
+                </a:lnTo>
+                <a:close/>
+                <a:lnTo>
+                  <a:pt x="1034044" y="272253"/>
+                </a:lnTo>
+                <a:close/>
+                <a:lnTo>
+                  <a:pt x="1039171" y="270961"/>
+                </a:lnTo>
+                <a:close/>
+                <a:lnTo>
+                  <a:pt x="1044297" y="269672"/>
+                </a:lnTo>
+                <a:close/>
+                <a:lnTo>
+                  <a:pt x="1049423" y="268385"/>
+                </a:lnTo>
+                <a:close/>
+                <a:lnTo>
+                  <a:pt x="1054549" y="267101"/>
+                </a:lnTo>
+                <a:close/>
+                <a:lnTo>
+                  <a:pt x="1059673" y="265818"/>
+                </a:lnTo>
+                <a:close/>
+                <a:lnTo>
+                  <a:pt x="1064798" y="264538"/>
+                </a:lnTo>
+                <a:close/>
+                <a:lnTo>
+                  <a:pt x="1069923" y="263261"/>
+                </a:lnTo>
+                <a:close/>
+                <a:lnTo>
+                  <a:pt x="1075047" y="261988"/>
+                </a:lnTo>
+                <a:close/>
+                <a:lnTo>
+                  <a:pt x="1080172" y="260718"/>
+                </a:lnTo>
+                <a:close/>
+                <a:lnTo>
+                  <a:pt x="1085298" y="259452"/>
+                </a:lnTo>
+                <a:close/>
+                <a:lnTo>
+                  <a:pt x="1090424" y="258190"/>
+                </a:lnTo>
+                <a:close/>
+                <a:lnTo>
+                  <a:pt x="1095550" y="256933"/>
+                </a:lnTo>
+                <a:close/>
+                <a:lnTo>
+                  <a:pt x="1100676" y="255681"/>
+                </a:lnTo>
+                <a:close/>
+                <a:lnTo>
+                  <a:pt x="1105802" y="254432"/>
+                </a:lnTo>
+                <a:close/>
+                <a:lnTo>
+                  <a:pt x="1110926" y="253188"/>
+                </a:lnTo>
+                <a:close/>
+                <a:lnTo>
+                  <a:pt x="1116049" y="251948"/>
+                </a:lnTo>
+                <a:close/>
+                <a:lnTo>
+                  <a:pt x="1121171" y="250712"/>
+                </a:lnTo>
+                <a:close/>
+                <a:lnTo>
+                  <a:pt x="1126290" y="249480"/>
+                </a:lnTo>
+                <a:close/>
+                <a:lnTo>
+                  <a:pt x="1131408" y="248252"/>
+                </a:lnTo>
+                <a:close/>
+                <a:lnTo>
+                  <a:pt x="1136525" y="247028"/>
+                </a:lnTo>
+                <a:close/>
+                <a:lnTo>
+                  <a:pt x="1141642" y="245807"/>
+                </a:lnTo>
+                <a:close/>
+                <a:lnTo>
+                  <a:pt x="1146760" y="244589"/>
+                </a:lnTo>
+                <a:close/>
+                <a:lnTo>
+                  <a:pt x="1151878" y="243375"/>
+                </a:lnTo>
+                <a:close/>
+                <a:lnTo>
+                  <a:pt x="1156999" y="242163"/>
+                </a:lnTo>
+                <a:close/>
+                <a:lnTo>
+                  <a:pt x="1162121" y="240954"/>
+                </a:lnTo>
+                <a:close/>
+                <a:lnTo>
+                  <a:pt x="1167245" y="239748"/>
+                </a:lnTo>
+                <a:close/>
+                <a:lnTo>
+                  <a:pt x="1172370" y="238545"/>
+                </a:lnTo>
+                <a:close/>
+                <a:lnTo>
+                  <a:pt x="1177496" y="237344"/>
+                </a:lnTo>
+                <a:close/>
+                <a:lnTo>
+                  <a:pt x="1182622" y="236146"/>
+                </a:lnTo>
+                <a:close/>
+                <a:lnTo>
+                  <a:pt x="1187749" y="234951"/>
+                </a:lnTo>
+                <a:close/>
+                <a:lnTo>
+                  <a:pt x="1192877" y="233758"/>
+                </a:lnTo>
+                <a:close/>
+                <a:lnTo>
+                  <a:pt x="1198004" y="232568"/>
+                </a:lnTo>
+                <a:close/>
+                <a:lnTo>
+                  <a:pt x="1203130" y="231381"/>
+                </a:lnTo>
+                <a:close/>
+                <a:lnTo>
+                  <a:pt x="1208256" y="230197"/>
+                </a:lnTo>
+                <a:close/>
+                <a:lnTo>
+                  <a:pt x="1213380" y="229018"/>
+                </a:lnTo>
+                <a:close/>
+                <a:lnTo>
+                  <a:pt x="1218504" y="227841"/>
+                </a:lnTo>
+                <a:close/>
+                <a:lnTo>
+                  <a:pt x="1223625" y="226670"/>
+                </a:lnTo>
+                <a:close/>
+                <a:lnTo>
+                  <a:pt x="1228745" y="225502"/>
+                </a:lnTo>
+                <a:close/>
+                <a:lnTo>
+                  <a:pt x="1233863" y="224339"/>
+                </a:lnTo>
+                <a:close/>
+                <a:lnTo>
+                  <a:pt x="1238980" y="223180"/>
+                </a:lnTo>
+                <a:close/>
+                <a:lnTo>
+                  <a:pt x="1244097" y="222025"/>
+                </a:lnTo>
+                <a:close/>
+                <a:lnTo>
+                  <a:pt x="1249215" y="220874"/>
+                </a:lnTo>
+                <a:close/>
+                <a:lnTo>
+                  <a:pt x="1254333" y="219726"/>
+                </a:lnTo>
+                <a:close/>
+                <a:lnTo>
+                  <a:pt x="1259453" y="218581"/>
+                </a:lnTo>
+                <a:close/>
+                <a:lnTo>
+                  <a:pt x="1264575" y="217440"/>
+                </a:lnTo>
+                <a:close/>
+                <a:lnTo>
+                  <a:pt x="1269699" y="216301"/>
+                </a:lnTo>
+                <a:close/>
+                <a:lnTo>
+                  <a:pt x="1274824" y="215165"/>
+                </a:lnTo>
+                <a:close/>
+                <a:lnTo>
+                  <a:pt x="1279949" y="214030"/>
+                </a:lnTo>
+                <a:close/>
+                <a:lnTo>
+                  <a:pt x="1285076" y="212898"/>
+                </a:lnTo>
+                <a:close/>
+                <a:lnTo>
+                  <a:pt x="1290202" y="211767"/>
+                </a:lnTo>
+                <a:close/>
+                <a:lnTo>
+                  <a:pt x="1295328" y="210637"/>
+                </a:lnTo>
+                <a:close/>
+                <a:lnTo>
+                  <a:pt x="1300453" y="209508"/>
+                </a:lnTo>
+                <a:close/>
+                <a:lnTo>
+                  <a:pt x="1305578" y="208380"/>
+                </a:lnTo>
+                <a:close/>
+                <a:lnTo>
+                  <a:pt x="1310702" y="207255"/>
+                </a:lnTo>
+                <a:close/>
+                <a:lnTo>
+                  <a:pt x="1315827" y="206133"/>
+                </a:lnTo>
+                <a:close/>
+                <a:lnTo>
+                  <a:pt x="1320952" y="205015"/>
+                </a:lnTo>
+                <a:close/>
+                <a:lnTo>
+                  <a:pt x="1326077" y="203902"/>
+                </a:lnTo>
+                <a:close/>
+                <a:lnTo>
+                  <a:pt x="1331202" y="202793"/>
+                </a:lnTo>
+                <a:close/>
+                <a:lnTo>
+                  <a:pt x="1336329" y="201690"/>
+                </a:lnTo>
+                <a:close/>
+                <a:lnTo>
+                  <a:pt x="1341455" y="200591"/>
+                </a:lnTo>
+                <a:close/>
+                <a:lnTo>
+                  <a:pt x="1346581" y="199496"/>
+                </a:lnTo>
+                <a:close/>
+                <a:lnTo>
+                  <a:pt x="1351706" y="198404"/>
+                </a:lnTo>
+                <a:close/>
+                <a:lnTo>
+                  <a:pt x="1356830" y="197315"/>
+                </a:lnTo>
+                <a:close/>
+                <a:lnTo>
+                  <a:pt x="1361953" y="196227"/>
+                </a:lnTo>
+                <a:close/>
+                <a:lnTo>
+                  <a:pt x="1367073" y="195139"/>
+                </a:lnTo>
+                <a:close/>
+                <a:lnTo>
+                  <a:pt x="1372192" y="194053"/>
+                </a:lnTo>
+                <a:close/>
+                <a:lnTo>
+                  <a:pt x="1377310" y="192968"/>
+                </a:lnTo>
+                <a:close/>
+                <a:lnTo>
+                  <a:pt x="1382427" y="191885"/>
+                </a:lnTo>
+                <a:close/>
+                <a:lnTo>
+                  <a:pt x="1387544" y="190805"/>
+                </a:lnTo>
+                <a:close/>
+                <a:lnTo>
+                  <a:pt x="1392662" y="189727"/>
+                </a:lnTo>
+                <a:close/>
+                <a:lnTo>
+                  <a:pt x="1397781" y="188653"/>
+                </a:lnTo>
+                <a:close/>
+                <a:lnTo>
+                  <a:pt x="1402902" y="187582"/>
+                </a:lnTo>
+                <a:close/>
+                <a:lnTo>
+                  <a:pt x="1408025" y="186516"/>
+                </a:lnTo>
+                <a:close/>
+                <a:lnTo>
+                  <a:pt x="1413149" y="185452"/>
+                </a:lnTo>
+                <a:close/>
+                <a:lnTo>
+                  <a:pt x="1418274" y="184392"/>
+                </a:lnTo>
+                <a:close/>
+                <a:lnTo>
+                  <a:pt x="1423401" y="183333"/>
+                </a:lnTo>
+                <a:close/>
+                <a:lnTo>
+                  <a:pt x="1428527" y="182277"/>
+                </a:lnTo>
+                <a:close/>
+                <a:lnTo>
+                  <a:pt x="1433655" y="181222"/>
+                </a:lnTo>
+                <a:close/>
+                <a:lnTo>
+                  <a:pt x="1438782" y="180168"/>
+                </a:lnTo>
+                <a:close/>
+                <a:lnTo>
+                  <a:pt x="1443909" y="179116"/>
+                </a:lnTo>
+                <a:close/>
+                <a:lnTo>
+                  <a:pt x="1449035" y="178065"/>
+                </a:lnTo>
+                <a:close/>
+                <a:lnTo>
+                  <a:pt x="1454160" y="177017"/>
+                </a:lnTo>
+                <a:close/>
+                <a:lnTo>
+                  <a:pt x="1459284" y="175971"/>
+                </a:lnTo>
+                <a:close/>
+                <a:lnTo>
+                  <a:pt x="1464407" y="174929"/>
+                </a:lnTo>
+                <a:close/>
+                <a:lnTo>
+                  <a:pt x="1469528" y="173890"/>
+                </a:lnTo>
+                <a:close/>
+                <a:lnTo>
+                  <a:pt x="1474647" y="172854"/>
+                </a:lnTo>
+                <a:close/>
+                <a:lnTo>
+                  <a:pt x="1479765" y="171822"/>
+                </a:lnTo>
+                <a:close/>
+                <a:lnTo>
+                  <a:pt x="1484882" y="170793"/>
+                </a:lnTo>
+                <a:close/>
+                <a:lnTo>
+                  <a:pt x="1490000" y="169767"/>
+                </a:lnTo>
+                <a:close/>
+                <a:lnTo>
+                  <a:pt x="1495117" y="168743"/>
+                </a:lnTo>
+                <a:close/>
+                <a:lnTo>
+                  <a:pt x="1500236" y="167721"/>
+                </a:lnTo>
+                <a:close/>
+                <a:lnTo>
+                  <a:pt x="1505356" y="166701"/>
+                </a:lnTo>
+                <a:close/>
+                <a:lnTo>
+                  <a:pt x="1510478" y="165683"/>
+                </a:lnTo>
+                <a:close/>
+                <a:lnTo>
+                  <a:pt x="1515602" y="164666"/>
+                </a:lnTo>
+                <a:close/>
+                <a:lnTo>
+                  <a:pt x="1520727" y="163651"/>
+                </a:lnTo>
+                <a:close/>
+                <a:lnTo>
+                  <a:pt x="1525853" y="162638"/>
+                </a:lnTo>
+                <a:close/>
+                <a:lnTo>
+                  <a:pt x="1530979" y="161626"/>
+                </a:lnTo>
+                <a:close/>
+                <a:lnTo>
+                  <a:pt x="1536106" y="160616"/>
+                </a:lnTo>
+                <a:close/>
+                <a:lnTo>
+                  <a:pt x="1541233" y="159607"/>
+                </a:lnTo>
+                <a:close/>
+                <a:lnTo>
+                  <a:pt x="1546360" y="158600"/>
+                </a:lnTo>
+                <a:close/>
+                <a:lnTo>
+                  <a:pt x="1551487" y="157595"/>
+                </a:lnTo>
+                <a:close/>
+                <a:lnTo>
+                  <a:pt x="1556613" y="156592"/>
+                </a:lnTo>
+                <a:close/>
+                <a:lnTo>
+                  <a:pt x="1561737" y="155593"/>
+                </a:lnTo>
+                <a:close/>
+                <a:lnTo>
+                  <a:pt x="1566861" y="154597"/>
+                </a:lnTo>
+                <a:close/>
+                <a:lnTo>
+                  <a:pt x="1571982" y="153604"/>
+                </a:lnTo>
+                <a:close/>
+                <a:lnTo>
+                  <a:pt x="1577102" y="152616"/>
+                </a:lnTo>
+                <a:close/>
+                <a:lnTo>
+                  <a:pt x="1582221" y="151631"/>
+                </a:lnTo>
+                <a:close/>
+                <a:lnTo>
+                  <a:pt x="1587338" y="150649"/>
+                </a:lnTo>
+                <a:close/>
+                <a:lnTo>
+                  <a:pt x="1592455" y="149670"/>
+                </a:lnTo>
+                <a:close/>
+                <a:lnTo>
+                  <a:pt x="1597572" y="148692"/>
+                </a:lnTo>
+                <a:close/>
+                <a:lnTo>
+                  <a:pt x="1602691" y="147715"/>
+                </a:lnTo>
+                <a:close/>
+                <a:lnTo>
+                  <a:pt x="1607810" y="146738"/>
+                </a:lnTo>
+                <a:close/>
+                <a:lnTo>
+                  <a:pt x="1612932" y="145760"/>
+                </a:lnTo>
+                <a:close/>
+                <a:lnTo>
+                  <a:pt x="1618056" y="144783"/>
+                </a:lnTo>
+                <a:close/>
+                <a:lnTo>
+                  <a:pt x="1623180" y="143806"/>
+                </a:lnTo>
+                <a:close/>
+                <a:lnTo>
+                  <a:pt x="1628306" y="142831"/>
+                </a:lnTo>
+                <a:close/>
+                <a:lnTo>
+                  <a:pt x="1633433" y="141858"/>
+                </a:lnTo>
+                <a:close/>
+                <a:lnTo>
+                  <a:pt x="1638559" y="140888"/>
+                </a:lnTo>
+                <a:close/>
+                <a:lnTo>
+                  <a:pt x="1643685" y="139922"/>
+                </a:lnTo>
+                <a:close/>
+                <a:lnTo>
+                  <a:pt x="1648810" y="138959"/>
+                </a:lnTo>
+                <a:close/>
+                <a:lnTo>
+                  <a:pt x="1653935" y="138000"/>
+                </a:lnTo>
+                <a:close/>
+                <a:lnTo>
+                  <a:pt x="1659059" y="137045"/>
+                </a:lnTo>
+                <a:close/>
+                <a:lnTo>
+                  <a:pt x="1664184" y="136092"/>
+                </a:lnTo>
+                <a:close/>
+                <a:lnTo>
+                  <a:pt x="1669309" y="135143"/>
+                </a:lnTo>
+                <a:close/>
+                <a:lnTo>
+                  <a:pt x="1674434" y="134195"/>
+                </a:lnTo>
+                <a:close/>
+                <a:lnTo>
+                  <a:pt x="1679559" y="133250"/>
+                </a:lnTo>
+                <a:close/>
+                <a:lnTo>
+                  <a:pt x="1684686" y="132307"/>
+                </a:lnTo>
+                <a:close/>
+                <a:lnTo>
+                  <a:pt x="1689812" y="131366"/>
+                </a:lnTo>
+                <a:close/>
+                <a:lnTo>
+                  <a:pt x="1694938" y="130426"/>
+                </a:lnTo>
+                <a:close/>
+                <a:lnTo>
+                  <a:pt x="1700063" y="129486"/>
+                </a:lnTo>
+                <a:close/>
+                <a:lnTo>
+                  <a:pt x="1705187" y="128547"/>
+                </a:lnTo>
+                <a:close/>
+                <a:lnTo>
+                  <a:pt x="1710310" y="127609"/>
+                </a:lnTo>
+                <a:close/>
+                <a:lnTo>
+                  <a:pt x="1715431" y="126671"/>
+                </a:lnTo>
+                <a:close/>
+                <a:lnTo>
+                  <a:pt x="1720550" y="125732"/>
+                </a:lnTo>
+                <a:close/>
+                <a:lnTo>
+                  <a:pt x="1725667" y="124795"/>
+                </a:lnTo>
+                <a:close/>
+                <a:lnTo>
+                  <a:pt x="1730784" y="123859"/>
+                </a:lnTo>
+                <a:close/>
+                <a:lnTo>
+                  <a:pt x="1735902" y="122926"/>
+                </a:lnTo>
+                <a:close/>
+                <a:lnTo>
+                  <a:pt x="1741019" y="121996"/>
+                </a:lnTo>
+                <a:close/>
+                <a:lnTo>
+                  <a:pt x="1746138" y="121069"/>
+                </a:lnTo>
+                <a:close/>
+                <a:lnTo>
+                  <a:pt x="1751259" y="120147"/>
+                </a:lnTo>
+                <a:close/>
+                <a:lnTo>
+                  <a:pt x="1756382" y="119228"/>
+                </a:lnTo>
+                <a:close/>
+                <a:lnTo>
+                  <a:pt x="1761506" y="118313"/>
+                </a:lnTo>
+                <a:close/>
+                <a:lnTo>
+                  <a:pt x="1766631" y="117401"/>
+                </a:lnTo>
+                <a:close/>
+                <a:lnTo>
+                  <a:pt x="1771757" y="116490"/>
+                </a:lnTo>
+                <a:close/>
+                <a:lnTo>
+                  <a:pt x="1776884" y="115581"/>
+                </a:lnTo>
+                <a:close/>
+                <a:lnTo>
+                  <a:pt x="1782011" y="114672"/>
+                </a:lnTo>
+                <a:close/>
+                <a:lnTo>
+                  <a:pt x="1787139" y="113763"/>
+                </a:lnTo>
+                <a:close/>
+                <a:lnTo>
+                  <a:pt x="1792265" y="112854"/>
+                </a:lnTo>
+                <a:close/>
+                <a:lnTo>
+                  <a:pt x="1797392" y="111945"/>
+                </a:lnTo>
+                <a:close/>
+                <a:lnTo>
+                  <a:pt x="1802517" y="111038"/>
+                </a:lnTo>
+                <a:close/>
+                <a:lnTo>
+                  <a:pt x="1807642" y="110131"/>
+                </a:lnTo>
+                <a:close/>
+                <a:lnTo>
+                  <a:pt x="1812764" y="109227"/>
+                </a:lnTo>
+                <a:close/>
+                <a:lnTo>
+                  <a:pt x="1817885" y="108325"/>
+                </a:lnTo>
+                <a:close/>
+                <a:lnTo>
+                  <a:pt x="1823005" y="107425"/>
+                </a:lnTo>
+                <a:close/>
+                <a:lnTo>
+                  <a:pt x="1828122" y="106528"/>
+                </a:lnTo>
+                <a:close/>
+                <a:lnTo>
+                  <a:pt x="1833240" y="105634"/>
+                </a:lnTo>
+                <a:close/>
+                <a:lnTo>
+                  <a:pt x="1838357" y="104741"/>
+                </a:lnTo>
+                <a:close/>
+                <a:lnTo>
+                  <a:pt x="1843474" y="103851"/>
+                </a:lnTo>
+                <a:close/>
+                <a:lnTo>
+                  <a:pt x="1848593" y="102962"/>
+                </a:lnTo>
+                <a:close/>
+                <a:lnTo>
+                  <a:pt x="1853713" y="102075"/>
+                </a:lnTo>
+                <a:close/>
+                <a:lnTo>
+                  <a:pt x="1858836" y="101190"/>
+                </a:lnTo>
+                <a:close/>
+                <a:lnTo>
+                  <a:pt x="1863960" y="100307"/>
+                </a:lnTo>
+                <a:close/>
+                <a:lnTo>
+                  <a:pt x="1869085" y="99425"/>
+                </a:lnTo>
+                <a:close/>
+                <a:lnTo>
+                  <a:pt x="1874211" y="98546"/>
+                </a:lnTo>
+                <a:close/>
+                <a:lnTo>
+                  <a:pt x="1879337" y="97669"/>
+                </a:lnTo>
+                <a:close/>
+                <a:lnTo>
+                  <a:pt x="1884464" y="96794"/>
+                </a:lnTo>
+                <a:close/>
+                <a:lnTo>
+                  <a:pt x="1889589" y="95922"/>
+                </a:lnTo>
+                <a:close/>
+                <a:lnTo>
+                  <a:pt x="1894715" y="95052"/>
+                </a:lnTo>
+                <a:close/>
+                <a:lnTo>
+                  <a:pt x="1899839" y="94184"/>
+                </a:lnTo>
+                <a:close/>
+                <a:lnTo>
+                  <a:pt x="1904964" y="93318"/>
+                </a:lnTo>
+                <a:close/>
+                <a:lnTo>
+                  <a:pt x="1910088" y="92453"/>
+                </a:lnTo>
+                <a:close/>
+                <a:lnTo>
+                  <a:pt x="1915213" y="91589"/>
+                </a:lnTo>
+                <a:close/>
+                <a:lnTo>
+                  <a:pt x="1920338" y="90725"/>
+                </a:lnTo>
+                <a:close/>
+                <a:lnTo>
+                  <a:pt x="1925464" y="89862"/>
+                </a:lnTo>
+                <a:close/>
+                <a:lnTo>
+                  <a:pt x="1930590" y="88999"/>
+                </a:lnTo>
+                <a:close/>
+                <a:lnTo>
+                  <a:pt x="1935717" y="88137"/>
+                </a:lnTo>
+                <a:close/>
+                <a:lnTo>
+                  <a:pt x="1940843" y="87276"/>
+                </a:lnTo>
+                <a:close/>
+                <a:lnTo>
+                  <a:pt x="1945968" y="86417"/>
+                </a:lnTo>
+                <a:close/>
+                <a:lnTo>
+                  <a:pt x="1951091" y="85560"/>
+                </a:lnTo>
+                <a:close/>
+                <a:lnTo>
+                  <a:pt x="1956213" y="84705"/>
+                </a:lnTo>
+                <a:close/>
+                <a:lnTo>
+                  <a:pt x="1961333" y="83853"/>
+                </a:lnTo>
+                <a:close/>
+                <a:lnTo>
+                  <a:pt x="1966452" y="83004"/>
+                </a:lnTo>
+                <a:close/>
+                <a:lnTo>
+                  <a:pt x="1971569" y="82157"/>
+                </a:lnTo>
+                <a:close/>
+                <a:lnTo>
+                  <a:pt x="1976686" y="81311"/>
+                </a:lnTo>
+                <a:close/>
+                <a:lnTo>
+                  <a:pt x="1981803" y="80467"/>
+                </a:lnTo>
+                <a:close/>
+                <a:lnTo>
+                  <a:pt x="1986922" y="79624"/>
+                </a:lnTo>
+                <a:close/>
+                <a:lnTo>
+                  <a:pt x="1992041" y="78781"/>
+                </a:lnTo>
+                <a:close/>
+                <a:lnTo>
+                  <a:pt x="1997163" y="77938"/>
+                </a:lnTo>
+                <a:close/>
+                <a:lnTo>
+                  <a:pt x="2002286" y="77096"/>
+                </a:lnTo>
+                <a:close/>
+                <a:lnTo>
+                  <a:pt x="2007410" y="76255"/>
+                </a:lnTo>
+                <a:close/>
+                <a:lnTo>
+                  <a:pt x="2012536" y="75415"/>
+                </a:lnTo>
+                <a:close/>
+                <a:lnTo>
+                  <a:pt x="2017663" y="74577"/>
+                </a:lnTo>
+                <a:close/>
+                <a:lnTo>
+                  <a:pt x="2022790" y="73740"/>
+                </a:lnTo>
+                <a:close/>
+                <a:lnTo>
+                  <a:pt x="2027917" y="72906"/>
+                </a:lnTo>
+                <a:close/>
+                <a:lnTo>
+                  <a:pt x="2033044" y="72074"/>
+                </a:lnTo>
+                <a:close/>
+                <a:lnTo>
+                  <a:pt x="2038171" y="71244"/>
+                </a:lnTo>
+                <a:close/>
+                <a:lnTo>
+                  <a:pt x="2043297" y="70416"/>
+                </a:lnTo>
+                <a:close/>
+                <a:lnTo>
+                  <a:pt x="2048422" y="69591"/>
+                </a:lnTo>
+                <a:close/>
+                <a:lnTo>
+                  <a:pt x="2053545" y="68768"/>
+                </a:lnTo>
+                <a:close/>
+                <a:lnTo>
+                  <a:pt x="2058668" y="67947"/>
+                </a:lnTo>
+                <a:close/>
+                <a:lnTo>
+                  <a:pt x="2063788" y="67129"/>
+                </a:lnTo>
+                <a:close/>
+                <a:lnTo>
+                  <a:pt x="2068907" y="66312"/>
+                </a:lnTo>
+                <a:close/>
+                <a:lnTo>
+                  <a:pt x="2074024" y="65498"/>
+                </a:lnTo>
+                <a:close/>
+                <a:lnTo>
+                  <a:pt x="2079141" y="64685"/>
+                </a:lnTo>
+                <a:close/>
+                <a:lnTo>
+                  <a:pt x="2084258" y="63873"/>
+                </a:lnTo>
+                <a:close/>
+                <a:lnTo>
+                  <a:pt x="2089376" y="63063"/>
+                </a:lnTo>
+                <a:close/>
+                <a:lnTo>
+                  <a:pt x="2094496" y="62254"/>
+                </a:lnTo>
+                <a:close/>
+                <a:lnTo>
+                  <a:pt x="2099617" y="61445"/>
+                </a:lnTo>
+                <a:close/>
+                <a:lnTo>
+                  <a:pt x="2104740" y="60638"/>
+                </a:lnTo>
+                <a:close/>
+                <a:lnTo>
+                  <a:pt x="2109864" y="59831"/>
+                </a:lnTo>
+                <a:close/>
+                <a:lnTo>
+                  <a:pt x="2114990" y="59025"/>
+                </a:lnTo>
+                <a:close/>
+                <a:lnTo>
+                  <a:pt x="2120116" y="58219"/>
+                </a:lnTo>
+                <a:close/>
+                <a:lnTo>
+                  <a:pt x="2125242" y="57415"/>
+                </a:lnTo>
+                <a:close/>
+                <a:lnTo>
+                  <a:pt x="2130368" y="56610"/>
+                </a:lnTo>
+                <a:close/>
+                <a:lnTo>
+                  <a:pt x="2135494" y="55807"/>
+                </a:lnTo>
+                <a:close/>
+                <a:lnTo>
+                  <a:pt x="2140619" y="55004"/>
+                </a:lnTo>
+                <a:close/>
+                <a:lnTo>
+                  <a:pt x="2145744" y="54203"/>
+                </a:lnTo>
+                <a:close/>
+                <a:lnTo>
+                  <a:pt x="2150868" y="53403"/>
+                </a:lnTo>
+                <a:close/>
+                <a:lnTo>
+                  <a:pt x="2155993" y="52605"/>
+                </a:lnTo>
+                <a:close/>
+                <a:lnTo>
+                  <a:pt x="2161118" y="51809"/>
+                </a:lnTo>
+                <a:close/>
+                <a:lnTo>
+                  <a:pt x="2166243" y="51015"/>
+                </a:lnTo>
+                <a:close/>
+                <a:lnTo>
+                  <a:pt x="2171369" y="50224"/>
+                </a:lnTo>
+                <a:close/>
+                <a:lnTo>
+                  <a:pt x="2176495" y="49435"/>
+                </a:lnTo>
+                <a:close/>
+                <a:lnTo>
+                  <a:pt x="2181622" y="48648"/>
+                </a:lnTo>
+                <a:close/>
+                <a:lnTo>
+                  <a:pt x="2186747" y="47863"/>
+                </a:lnTo>
+                <a:close/>
+                <a:lnTo>
+                  <a:pt x="2191872" y="47080"/>
+                </a:lnTo>
+                <a:close/>
+                <a:lnTo>
+                  <a:pt x="2196995" y="46297"/>
+                </a:lnTo>
+                <a:close/>
+                <a:lnTo>
+                  <a:pt x="2202116" y="45516"/>
+                </a:lnTo>
+                <a:close/>
+                <a:lnTo>
+                  <a:pt x="2207236" y="44735"/>
+                </a:lnTo>
+                <a:close/>
+                <a:lnTo>
+                  <a:pt x="2212354" y="43955"/>
+                </a:lnTo>
+                <a:close/>
+                <a:lnTo>
+                  <a:pt x="2217471" y="43175"/>
+                </a:lnTo>
+                <a:close/>
+                <a:lnTo>
+                  <a:pt x="2222588" y="42396"/>
+                </a:lnTo>
+                <a:close/>
+                <a:lnTo>
+                  <a:pt x="2227705" y="41618"/>
+                </a:lnTo>
+                <a:close/>
+                <a:lnTo>
+                  <a:pt x="2232824" y="40840"/>
+                </a:lnTo>
+                <a:close/>
+                <a:lnTo>
+                  <a:pt x="2237944" y="40063"/>
+                </a:lnTo>
+                <a:close/>
+                <a:lnTo>
+                  <a:pt x="2243066" y="39287"/>
+                </a:lnTo>
+                <a:close/>
+                <a:lnTo>
+                  <a:pt x="2248190" y="38512"/>
+                </a:lnTo>
+                <a:close/>
+                <a:lnTo>
+                  <a:pt x="2253315" y="37738"/>
+                </a:lnTo>
+                <a:close/>
+                <a:lnTo>
+                  <a:pt x="2258441" y="36966"/>
+                </a:lnTo>
+                <a:close/>
+                <a:lnTo>
+                  <a:pt x="2263568" y="36196"/>
+                </a:lnTo>
+                <a:close/>
+                <a:lnTo>
+                  <a:pt x="2268695" y="35429"/>
+                </a:lnTo>
+                <a:close/>
+                <a:lnTo>
+                  <a:pt x="2273822" y="34663"/>
+                </a:lnTo>
+                <a:close/>
+                <a:lnTo>
+                  <a:pt x="2278949" y="33901"/>
+                </a:lnTo>
+                <a:close/>
+                <a:lnTo>
+                  <a:pt x="2284075" y="33140"/>
+                </a:lnTo>
+                <a:close/>
+                <a:lnTo>
+                  <a:pt x="2289201" y="32381"/>
+                </a:lnTo>
+                <a:close/>
+                <a:lnTo>
+                  <a:pt x="2294326" y="31624"/>
+                </a:lnTo>
+                <a:close/>
+                <a:lnTo>
+                  <a:pt x="2299449" y="30868"/>
+                </a:lnTo>
+                <a:close/>
+                <a:lnTo>
+                  <a:pt x="2304571" y="30112"/>
+                </a:lnTo>
+                <a:close/>
+                <a:lnTo>
+                  <a:pt x="2309690" y="29358"/>
+                </a:lnTo>
+                <a:close/>
+                <a:lnTo>
+                  <a:pt x="2314809" y="28604"/>
+                </a:lnTo>
+                <a:close/>
+                <a:lnTo>
+                  <a:pt x="2319926" y="27850"/>
+                </a:lnTo>
+                <a:close/>
+                <a:lnTo>
+                  <a:pt x="2325043" y="27098"/>
+                </a:lnTo>
+                <a:close/>
+                <a:lnTo>
+                  <a:pt x="2330160" y="26346"/>
+                </a:lnTo>
+                <a:close/>
+                <a:lnTo>
+                  <a:pt x="2335279" y="25596"/>
+                </a:lnTo>
+                <a:close/>
+                <a:lnTo>
+                  <a:pt x="2340398" y="24846"/>
+                </a:lnTo>
+                <a:close/>
+                <a:lnTo>
+                  <a:pt x="2345520" y="24098"/>
+                </a:lnTo>
+                <a:close/>
+                <a:lnTo>
+                  <a:pt x="2350644" y="23351"/>
+                </a:lnTo>
+                <a:close/>
+                <a:lnTo>
+                  <a:pt x="2355769" y="22605"/>
+                </a:lnTo>
+                <a:close/>
+                <a:lnTo>
+                  <a:pt x="2360895" y="21860"/>
+                </a:lnTo>
+                <a:close/>
+                <a:lnTo>
+                  <a:pt x="2366021" y="21115"/>
+                </a:lnTo>
+                <a:close/>
+                <a:lnTo>
+                  <a:pt x="2371147" y="20371"/>
+                </a:lnTo>
+                <a:close/>
+                <a:lnTo>
+                  <a:pt x="2376273" y="19628"/>
+                </a:lnTo>
+                <a:close/>
+                <a:lnTo>
+                  <a:pt x="2381399" y="18885"/>
+                </a:lnTo>
+                <a:close/>
+                <a:lnTo>
+                  <a:pt x="2386523" y="18143"/>
+                </a:lnTo>
+                <a:close/>
+                <a:lnTo>
+                  <a:pt x="2391648" y="17402"/>
+                </a:lnTo>
+                <a:close/>
+                <a:lnTo>
+                  <a:pt x="2396773" y="16663"/>
+                </a:lnTo>
+                <a:close/>
+                <a:lnTo>
+                  <a:pt x="2401897" y="15926"/>
+                </a:lnTo>
+                <a:close/>
+                <a:lnTo>
+                  <a:pt x="2407022" y="15192"/>
+                </a:lnTo>
+                <a:close/>
+                <a:lnTo>
+                  <a:pt x="2412148" y="14460"/>
+                </a:lnTo>
+                <a:close/>
+                <a:lnTo>
+                  <a:pt x="2417274" y="13732"/>
+                </a:lnTo>
+                <a:close/>
+                <a:lnTo>
+                  <a:pt x="2422400" y="13005"/>
+                </a:lnTo>
+                <a:close/>
+                <a:lnTo>
+                  <a:pt x="2427526" y="12280"/>
+                </a:lnTo>
+                <a:close/>
+                <a:lnTo>
+                  <a:pt x="2432651" y="11557"/>
+                </a:lnTo>
+                <a:close/>
+                <a:lnTo>
+                  <a:pt x="2437775" y="10833"/>
+                </a:lnTo>
+                <a:close/>
+                <a:lnTo>
+                  <a:pt x="2442898" y="10110"/>
+                </a:lnTo>
+                <a:close/>
+                <a:lnTo>
+                  <a:pt x="2448019" y="9385"/>
+                </a:lnTo>
+                <a:close/>
+                <a:lnTo>
+                  <a:pt x="2453139" y="8660"/>
+                </a:lnTo>
+                <a:close/>
+                <a:lnTo>
+                  <a:pt x="2458257" y="7934"/>
+                </a:lnTo>
+                <a:close/>
+                <a:lnTo>
+                  <a:pt x="2463375" y="7208"/>
+                </a:lnTo>
+                <a:close/>
+                <a:lnTo>
+                  <a:pt x="2468492" y="6483"/>
+                </a:lnTo>
+                <a:close/>
+                <a:lnTo>
+                  <a:pt x="2473609" y="5757"/>
+                </a:lnTo>
+                <a:close/>
+                <a:lnTo>
+                  <a:pt x="2478727" y="5032"/>
+                </a:lnTo>
+                <a:close/>
+                <a:lnTo>
+                  <a:pt x="2483846" y="4308"/>
+                </a:lnTo>
+                <a:close/>
+                <a:lnTo>
+                  <a:pt x="2488965" y="3585"/>
+                </a:lnTo>
+                <a:close/>
+                <a:lnTo>
+                  <a:pt x="2494087" y="2864"/>
+                </a:lnTo>
+                <a:close/>
+                <a:lnTo>
+                  <a:pt x="2499211" y="2145"/>
+                </a:lnTo>
+                <a:close/>
+                <a:lnTo>
+                  <a:pt x="2504338" y="1427"/>
+                </a:lnTo>
+                <a:close/>
+                <a:lnTo>
+                  <a:pt x="2509467" y="712"/>
+                </a:lnTo>
+                <a:close/>
+                <a:lnTo>
+                  <a:pt x="2514600" y="0"/>
                 </a:lnTo>
                 <a:close/>
               </a:path>
@@ -5623,8 +5623,8 @@
         </p:nvCxnSpPr>
         <p:spPr>
           <a:xfrm flipV="1">
-            <a:off x="6172200.0" y="1428750.0"/>
-            <a:ext cx="0.0" cy="1143000.0"/>
+            <a:off x="6400800.0" y="1840230.0"/>
+            <a:ext cx="0.0" cy="731520.0"/>
           </a:xfrm>
           <a:prstGeom prst="line">
             <a:avLst/>
@@ -5659,7 +5659,7 @@
         </p:nvSpPr>
         <p:spPr>
           <a:xfrm>
-            <a:off x="6083300" y="1339850"/>
+            <a:off x="6311900" y="1751330"/>
             <a:ext cx="177800" cy="177800"/>
           </a:xfrm>
           <a:prstGeom prst="ellipse">
@@ -5704,7 +5704,7 @@
         </p:nvSpPr>
         <p:spPr>
           <a:xfrm>
-            <a:off x="6146800" y="791210"/>
+            <a:off x="6146800" y="1248410"/>
             <a:ext cx="1524000" cy="508000"/>
           </a:xfrm>
           <a:prstGeom prst="rect">
@@ -5740,7 +5740,7 @@
         </p:nvSpPr>
         <p:spPr>
           <a:xfrm>
-            <a:off x="5918200" y="2391410"/>
+            <a:off x="6146800" y="2368550"/>
             <a:ext cx="1524000" cy="508000"/>
           </a:xfrm>
           <a:prstGeom prst="rect">
@@ -5776,7 +5776,7 @@
         </p:nvSpPr>
         <p:spPr>
           <a:xfrm>
-            <a:off x="4180840" y="2391410"/>
+            <a:off x="4203700" y="2368550"/>
             <a:ext cx="1524000" cy="508000"/>
           </a:xfrm>
           <a:prstGeom prst="rect">

</xml_diff>